<commit_message>
Admin panel, dual tour assembly, nav and link fixes
</commit_message>
<xml_diff>
--- a/docs/Diploma_Defense.pptx
+++ b/docs/Diploma_Defense.pptx
@@ -17,9 +17,6 @@
     <p:sldId id="266" r:id="rId12"/>
     <p:sldId id="267" r:id="rId13"/>
     <p:sldId id="268" r:id="rId14"/>
-    <p:sldId id="269" r:id="rId15"/>
-    <p:sldId id="270" r:id="rId16"/>
-    <p:sldId id="271" r:id="rId17"/>
   </p:sldIdLst>
   <p:sldSz cx="12192000" cy="6858000" type="screen16x9"/>
   <p:notesSz cx="6858000" cy="9144000"/>
@@ -85,7 +82,7 @@
                 </a:solidFill>
                 <a:latin typeface="Calibri"/>
               </a:rPr>
-              <a:t>Здравствуйте. Представляю дипломный проект — модуль AI-подбора туров для «Бон Вояж» / «Планета 360».</a:t>
+              <a:t>Здравствуйте, уважаемые члены комиссии. Представляю ВКР — систему «AI Тур-Генератор» для ООО «Бон Вояж» (сайт Планета 360 / bon-voyage28.ru).</a:t>
             </a:r>
           </a:p>
         </p:txBody>
@@ -134,7 +131,7 @@
                 </a:solidFill>
                 <a:latin typeface="Calibri"/>
               </a:rPr>
-              <a:t>Демо: http://localhost:8000</a:t>
+              <a:t>Цифры из главы 5 диплома. При ~20 обращениях в день модуль окупается за 3–4 месяца.</a:t>
             </a:r>
           </a:p>
         </p:txBody>
@@ -183,7 +180,7 @@
                 </a:solidFill>
                 <a:latin typeface="Calibri"/>
               </a:rPr>
-              <a:t>Результаты в главе 3.4.</a:t>
+              <a:t>Практическая значимость: снижение нагрузки на менеджеров, круглосуточный приём заявок, ускорение подбора тура.</a:t>
             </a:r>
           </a:p>
         </p:txBody>
@@ -232,154 +229,7 @@
                 </a:solidFill>
                 <a:latin typeface="Calibri"/>
               </a:rPr>
-              <a:t>Цифры из главы 5.</a:t>
-            </a:r>
-          </a:p>
-        </p:txBody>
-      </p:sp>
-    </p:spTree>
-  </p:cSld>
-</p:notes>
-</file>
-
-<file path=ppt/notesSlides/notesSlide13.xml><?xml version="1.0" encoding="utf-8"?>
-<p:notes xmlns:a="http://schemas.openxmlformats.org/drawingml/2006/main" xmlns:r="http://schemas.openxmlformats.org/officeDocument/2006/relationships" xmlns:p="http://schemas.openxmlformats.org/presentationml/2006/main">
-  <p:cSld>
-    <p:spTree>
-      <p:nvGrpSpPr>
-        <p:cNvPr id="1" name=""/>
-        <p:cNvGrpSpPr/>
-        <p:nvPr/>
-      </p:nvGrpSpPr>
-      <p:grpSpPr>
-        <a:xfrm>
-          <a:off x="0" y="0"/>
-          <a:ext cx="0" cy="0"/>
-        </a:xfrm>
-      </p:grpSpPr>
-      <p:sp>
-        <p:nvSpPr>
-          <p:cNvPr id="2" name="N"/>
-          <p:cNvSpPr/>
-          <p:nvPr/>
-        </p:nvSpPr>
-        <p:spPr>
-          <a:xfrm>
-            <a:off x="685800" y="434340"/>
-            <a:ext cx="5486400" cy="4114800"/>
-          </a:xfrm>
-        </p:spPr>
-        <p:txBody>
-          <a:bodyPr/>
-          <a:lstStyle/>
-          <a:p>
-            <a:pPr algn="l"/>
-            <a:r>
-              <a:rPr sz="1800">
-                <a:solidFill>
-                  <a:srgbClr val="1E293B"/>
-                </a:solidFill>
-                <a:latin typeface="Calibri"/>
-              </a:rPr>
-              <a:t>Работающий прототип.</a:t>
-            </a:r>
-          </a:p>
-        </p:txBody>
-      </p:sp>
-    </p:spTree>
-  </p:cSld>
-</p:notes>
-</file>
-
-<file path=ppt/notesSlides/notesSlide14.xml><?xml version="1.0" encoding="utf-8"?>
-<p:notes xmlns:a="http://schemas.openxmlformats.org/drawingml/2006/main" xmlns:r="http://schemas.openxmlformats.org/officeDocument/2006/relationships" xmlns:p="http://schemas.openxmlformats.org/presentationml/2006/main">
-  <p:cSld>
-    <p:spTree>
-      <p:nvGrpSpPr>
-        <p:cNvPr id="1" name=""/>
-        <p:cNvGrpSpPr/>
-        <p:nvPr/>
-      </p:nvGrpSpPr>
-      <p:grpSpPr>
-        <a:xfrm>
-          <a:off x="0" y="0"/>
-          <a:ext cx="0" cy="0"/>
-        </a:xfrm>
-      </p:grpSpPr>
-      <p:sp>
-        <p:nvSpPr>
-          <p:cNvPr id="2" name="N"/>
-          <p:cNvSpPr/>
-          <p:nvPr/>
-        </p:nvSpPr>
-        <p:spPr>
-          <a:xfrm>
-            <a:off x="685800" y="434340"/>
-            <a:ext cx="5486400" cy="4114800"/>
-          </a:xfrm>
-        </p:spPr>
-        <p:txBody>
-          <a:bodyPr/>
-          <a:lstStyle/>
-          <a:p>
-            <a:pPr algn="l"/>
-            <a:r>
-              <a:rPr sz="1800">
-                <a:solidFill>
-                  <a:srgbClr val="1E293B"/>
-                </a:solidFill>
-                <a:latin typeface="Calibri"/>
-              </a:rPr>
-              <a:t>30 секунд. Уверенный финал.</a:t>
-            </a:r>
-          </a:p>
-        </p:txBody>
-      </p:sp>
-    </p:spTree>
-  </p:cSld>
-</p:notes>
-</file>
-
-<file path=ppt/notesSlides/notesSlide15.xml><?xml version="1.0" encoding="utf-8"?>
-<p:notes xmlns:a="http://schemas.openxmlformats.org/drawingml/2006/main" xmlns:r="http://schemas.openxmlformats.org/officeDocument/2006/relationships" xmlns:p="http://schemas.openxmlformats.org/presentationml/2006/main">
-  <p:cSld>
-    <p:spTree>
-      <p:nvGrpSpPr>
-        <p:cNvPr id="1" name=""/>
-        <p:cNvGrpSpPr/>
-        <p:nvPr/>
-      </p:nvGrpSpPr>
-      <p:grpSpPr>
-        <a:xfrm>
-          <a:off x="0" y="0"/>
-          <a:ext cx="0" cy="0"/>
-        </a:xfrm>
-      </p:grpSpPr>
-      <p:sp>
-        <p:nvSpPr>
-          <p:cNvPr id="2" name="N"/>
-          <p:cNvSpPr/>
-          <p:nvPr/>
-        </p:nvSpPr>
-        <p:spPr>
-          <a:xfrm>
-            <a:off x="685800" y="434340"/>
-            <a:ext cx="5486400" cy="4114800"/>
-          </a:xfrm>
-        </p:spPr>
-        <p:txBody>
-          <a:bodyPr/>
-          <a:lstStyle/>
-          <a:p>
-            <a:pPr algn="l"/>
-            <a:r>
-              <a:rPr sz="1800">
-                <a:solidFill>
-                  <a:srgbClr val="1E293B"/>
-                </a:solidFill>
-                <a:latin typeface="Calibri"/>
-              </a:rPr>
-              <a:t>Вопросы комиссии.</a:t>
+              <a:t>Спасибо. Готов ответить на вопросы и показать работу модуля.</a:t>
             </a:r>
           </a:p>
         </p:txBody>
@@ -428,7 +278,7 @@
                 </a:solidFill>
                 <a:latin typeface="Calibri"/>
               </a:rPr>
-              <a:t>Почему тема важна для турфирмы в Благовещенске.</a:t>
+              <a:t>Классический подбор тура медленный. ИИ позволяет принять запрос в свободной форме и быстро сформировать турпакет из каталога турфирмы.</a:t>
             </a:r>
           </a:p>
         </p:txBody>
@@ -477,7 +327,7 @@
                 </a:solidFill>
                 <a:latin typeface="Calibri"/>
               </a:rPr>
-              <a:t>Цель — одним предложением, задачи по заданию.</a:t>
+              <a:t>Цель — одним предложением. Задачи — по введению диплома.</a:t>
             </a:r>
           </a:p>
         </p:txBody>
@@ -526,7 +376,7 @@
                 </a:solidFill>
                 <a:latin typeface="Calibri"/>
               </a:rPr>
-              <a:t>Классический слайд защиты.</a:t>
+              <a:t>Обоснование собственной разработки: нужны естественный язык, уточняющие вопросы и данные именно «Бон Вояж».</a:t>
             </a:r>
           </a:p>
         </p:txBody>
@@ -575,7 +425,7 @@
                 </a:solidFill>
                 <a:latin typeface="Calibri"/>
               </a:rPr>
-              <a:t>Назовите стек и основные файлы проекта.</a:t>
+              <a:t>Объект — процесс, предмет — методы и алгоритмы с применением больших языковых моделей.</a:t>
             </a:r>
           </a:p>
         </p:txBody>
@@ -624,7 +474,7 @@
                 </a:solidFill>
                 <a:latin typeface="Calibri"/>
               </a:rPr>
-              <a:t>Опишите поток данных словами.</a:t>
+              <a:t>Клиент-серверная архитектура. Связка двух LLM даёт отказоустойчивость и соответствие 152-ФЗ (GigaChat).</a:t>
             </a:r>
           </a:p>
         </p:txBody>
@@ -673,7 +523,7 @@
                 </a:solidFill>
                 <a:latin typeface="Calibri"/>
               </a:rPr>
-              <a:t>Связь с бизнес-процессом организации.</a:t>
+              <a:t>ER-диаграмма из диплома. hotels — каталог туров (парсер), user_sessions — состояние диалога в JSON, generated_tours — готовые турпакеты.</a:t>
             </a:r>
           </a:p>
         </p:txBody>
@@ -722,7 +572,7 @@
                 </a:solidFill>
                 <a:latin typeface="Calibri"/>
               </a:rPr>
-              <a:t>Таблицы из database.py.</a:t>
+              <a:t>Можно показать демо: http://localhost:8000. Пример запроса: «Хочу в Китай с 10 по 20 июля, бюджет 80 000 руб.»</a:t>
             </a:r>
           </a:p>
         </p:txBody>
@@ -771,7 +621,7 @@
                 </a:solidFill>
                 <a:latin typeface="Calibri"/>
               </a:rPr>
-              <a:t>Ключевой слайд. Можно показать демо.</a:t>
+              <a:t>Асинхронная обработка: сервер не блокируется на время ответа нейросети (2–10 сек).</a:t>
             </a:r>
           </a:p>
         </p:txBody>
@@ -1058,7 +908,19 @@
                 </a:solidFill>
                 <a:latin typeface="Calibri Light"/>
               </a:rPr>
-              <a:t>Модуль динамической генерации турпакета</a:t>
+              <a:t>Проектирование и разработка системы</a:t>
+            </a:r>
+            <a:r>
+              <a:rPr sz="2600" b="1">
+                <a:solidFill>
+                  <a:srgbClr val="FFFFFF"/>
+                </a:solidFill>
+                <a:latin typeface="Calibri Light"/>
+              </a:rPr>
+              <a:t>
+                <a:br/>
+                динамической сборки турпакетов
+              </a:t>
             </a:r>
             <a:r>
               <a:rPr sz="2600" b="1">
@@ -1108,7 +970,7 @@
                 </a:solidFill>
                 <a:latin typeface="Calibri"/>
               </a:rPr>
-              <a:t>Студент: ФИО</a:t>
+              <a:t>Студент: Ю.В. Тымченко</a:t>
             </a:r>
           </a:p>
           <a:p>
@@ -1122,7 +984,7 @@
                 </a:solidFill>
                 <a:latin typeface="Calibri"/>
               </a:rPr>
-              <a:t>Группа: ______</a:t>
+              <a:t>Специальность: 09.02.07 — Информатика, программирование и эксплуатация БАС</a:t>
             </a:r>
           </a:p>
           <a:p>
@@ -1136,7 +998,7 @@
                 </a:solidFill>
                 <a:latin typeface="Calibri"/>
               </a:rPr>
-              <a:t>Специальность: 09.02.07 Информационные системы и программирование</a:t>
+              <a:t>База практики: ООО «Бон Вояж»</a:t>
             </a:r>
           </a:p>
           <a:p>
@@ -1150,7 +1012,7 @@
                 </a:solidFill>
                 <a:latin typeface="Calibri"/>
               </a:rPr>
-              <a:t>Руководитель: ФИО</a:t>
+              <a:t>Руководитель: Д.П. Бардин</a:t>
             </a:r>
           </a:p>
           <a:p>
@@ -1164,7 +1026,7 @@
                 </a:solidFill>
                 <a:latin typeface="Calibri"/>
               </a:rPr>
-              <a:t>ГБПОУ «Амурский технический колледж» · 2026</a:t>
+              <a:t>ГБПОУ «Благовещенский политехнический колледж» · 2026</a:t>
             </a:r>
           </a:p>
         </p:txBody>
@@ -1443,7 +1305,7 @@
                 </a:solidFill>
                 <a:latin typeface="Calibri"/>
               </a:rPr>
-              <a:t>10 / 15</a:t>
+              <a:t>10 / 12</a:t>
             </a:r>
           </a:p>
         </p:txBody>
@@ -1563,7 +1425,7 @@
                 </a:solidFill>
                 <a:latin typeface="Calibri Light"/>
               </a:rPr>
-              <a:t>Клиентский интерфейс</a:t>
+              <a:t>Экономическое обоснование</a:t>
             </a:r>
           </a:p>
         </p:txBody>
@@ -1601,7 +1463,7 @@
                 </a:solidFill>
                 <a:latin typeface="Calibri"/>
               </a:rPr>
-              <a:t>Веб-чат на Vue.js</a:t>
+              <a:t>Затраты на разработку: 107 200 руб.</a:t>
             </a:r>
           </a:p>
           <a:p>
@@ -1615,7 +1477,7 @@
                 </a:solidFill>
                 <a:latin typeface="Calibri"/>
               </a:rPr>
-              <a:t>Свободный ввод на русском языке</a:t>
+              <a:t>Эксплуатация: 47 100 руб./год</a:t>
             </a:r>
           </a:p>
           <a:p>
@@ -1629,7 +1491,21 @@
                 </a:solidFill>
                 <a:latin typeface="Calibri"/>
               </a:rPr>
-              <a:t>Карточка тура и форма заявки</a:t>
+              <a:t>Эффект от внедрения: 664 200 руб./год</a:t>
+            </a:r>
+          </a:p>
+          <a:p>
+            <a:pPr marL="280000" indent="-140000" spcAft="700">
+              <a:buChar char="●"/>
+            </a:pPr>
+            <a:r>
+              <a:rPr sz="1620">
+                <a:solidFill>
+                  <a:srgbClr val="1E293B"/>
+                </a:solidFill>
+                <a:latin typeface="Calibri"/>
+              </a:rPr>
+              <a:t>Окупаемость: 3–4 месяца</a:t>
             </a:r>
           </a:p>
         </p:txBody>
@@ -1665,7 +1541,7 @@
                 </a:solidFill>
                 <a:latin typeface="Calibri"/>
               </a:rPr>
-              <a:t>ШАПКА САЙТА</a:t>
+              <a:t>РАЗРАБОТКА</a:t>
             </a:r>
           </a:p>
           <a:p>
@@ -1677,7 +1553,7 @@
                 </a:solidFill>
                 <a:latin typeface="Calibri"/>
               </a:rPr>
-              <a:t>· Логотип «Планета 360»</a:t>
+              <a:t>· 200 ч × 500 руб. = 100 000 руб.</a:t>
             </a:r>
           </a:p>
           <a:p>
@@ -1689,13 +1565,64 @@
                 </a:solidFill>
                 <a:latin typeface="Calibri"/>
               </a:rPr>
-              <a:t>· Навигация, телефон турфирмы</a:t>
+              <a:t>· Материалы = 7 720 руб.</a:t>
             </a:r>
           </a:p>
           <a:p>
             <a:pPr spcAft="200"/>
           </a:p>
           <a:p>
+            <a:pPr algn="l" spcAft="400"/>
+            <a:r>
+              <a:rPr sz="1500" b="1">
+                <a:solidFill>
+                  <a:srgbClr val="01773A"/>
+                </a:solidFill>
+                <a:latin typeface="Calibri"/>
+              </a:rPr>
+              <a:t>АЛЬТЕРНАТИВЫ</a:t>
+            </a:r>
+          </a:p>
+          <a:p>
+            <a:pPr algn="l" spcAft="100"/>
+            <a:r>
+              <a:rPr sz="1450">
+                <a:solidFill>
+                  <a:srgbClr val="1E293B"/>
+                </a:solidFill>
+                <a:latin typeface="Calibri"/>
+              </a:rPr>
+              <a:t>· Доп. менеджер ≈ 420 000 руб./год</a:t>
+            </a:r>
+          </a:p>
+          <a:p>
+            <a:pPr algn="l" spcAft="100"/>
+            <a:r>
+              <a:rPr sz="1450">
+                <a:solidFill>
+                  <a:srgbClr val="1E293B"/>
+                </a:solidFill>
+                <a:latin typeface="Calibri"/>
+              </a:rPr>
+              <a:t>· Готовый чат-бот ≈ 50–120 тыс./год</a:t>
+            </a:r>
+          </a:p>
+          <a:p>
+            <a:pPr spcAft="200"/>
+          </a:p>
+          <a:p>
+            <a:pPr algn="l" spcAft="400"/>
+            <a:r>
+              <a:rPr sz="1500" b="1">
+                <a:solidFill>
+                  <a:srgbClr val="01773A"/>
+                </a:solidFill>
+                <a:latin typeface="Calibri"/>
+              </a:rPr>
+              <a:t>ВЫВОД</a:t>
+            </a:r>
+          </a:p>
+          <a:p>
             <a:pPr algn="l" spcAft="120"/>
             <a:r>
               <a:rPr sz="1450">
@@ -1704,11 +1631,11 @@
                 </a:solidFill>
                 <a:latin typeface="Calibri"/>
               </a:rPr>
-              <a:t>МОДУЛЬ «AI Тур-Генератор»</a:t>
-            </a:r>
-          </a:p>
-          <a:p>
-            <a:pPr algn="l" spcAft="100"/>
+              <a:t>Собственный модуль дешевле</a:t>
+            </a:r>
+          </a:p>
+          <a:p>
+            <a:pPr algn="l" spcAft="120"/>
             <a:r>
               <a:rPr sz="1450">
                 <a:solidFill>
@@ -1716,85 +1643,7 @@
                 </a:solidFill>
                 <a:latin typeface="Calibri"/>
               </a:rPr>
-              <a:t>· Выбор нейросети: Auto / GigaChat / DeepSeek</a:t>
-            </a:r>
-          </a:p>
-          <a:p>
-            <a:pPr algn="l" spcAft="100"/>
-            <a:r>
-              <a:rPr sz="1450">
-                <a:solidFill>
-                  <a:srgbClr val="1E293B"/>
-                </a:solidFill>
-                <a:latin typeface="Calibri"/>
-              </a:rPr>
-              <a:t>· Поле ввода: «Хочу в Китай…»</a:t>
-            </a:r>
-          </a:p>
-          <a:p>
-            <a:pPr algn="l" spcAft="100"/>
-            <a:r>
-              <a:rPr sz="1450">
-                <a:solidFill>
-                  <a:srgbClr val="1E293B"/>
-                </a:solidFill>
-                <a:latin typeface="Calibri"/>
-              </a:rPr>
-              <a:t>· Кнопки: Отправить, Сброс</a:t>
-            </a:r>
-          </a:p>
-          <a:p>
-            <a:pPr spcAft="200"/>
-          </a:p>
-          <a:p>
-            <a:pPr algn="l" spcAft="400"/>
-            <a:r>
-              <a:rPr sz="1500" b="1">
-                <a:solidFill>
-                  <a:srgbClr val="01773A"/>
-                </a:solidFill>
-                <a:latin typeface="Calibri"/>
-              </a:rPr>
-              <a:t>КАРТОЧКА ТУРА</a:t>
-            </a:r>
-          </a:p>
-          <a:p>
-            <a:pPr algn="l" spcAft="100"/>
-            <a:r>
-              <a:rPr sz="1450">
-                <a:solidFill>
-                  <a:srgbClr val="1E293B"/>
-                </a:solidFill>
-                <a:latin typeface="Calibri"/>
-              </a:rPr>
-              <a:t>· Отель, перелёт, даты, цена</a:t>
-            </a:r>
-          </a:p>
-          <a:p>
-            <a:pPr algn="l" spcAft="100"/>
-            <a:r>
-              <a:rPr sz="1450">
-                <a:solidFill>
-                  <a:srgbClr val="1E293B"/>
-                </a:solidFill>
-                <a:latin typeface="Calibri"/>
-              </a:rPr>
-              <a:t>· Кнопки: «Купить» / «Страница турфирмы»</a:t>
-            </a:r>
-          </a:p>
-          <a:p>
-            <a:pPr spcAft="200"/>
-          </a:p>
-          <a:p>
-            <a:pPr algn="l" spcAft="120"/>
-            <a:r>
-              <a:rPr sz="1450">
-                <a:solidFill>
-                  <a:srgbClr val="1E293B"/>
-                </a:solidFill>
-                <a:latin typeface="Calibri"/>
-              </a:rPr>
-              <a:t>ЗАЯВКА: имя, телефон, email → менеджеру</a:t>
+              <a:t>и использует каталог «Бон Вояж»</a:t>
             </a:r>
           </a:p>
         </p:txBody>
@@ -2073,21 +1922,21 @@
                 </a:solidFill>
                 <a:latin typeface="Calibri"/>
               </a:rPr>
-              <a:t>11 / 15</a:t>
-            </a:r>
-          </a:p>
-        </p:txBody>
-      </p:sp>
-      <p:sp>
-        <p:nvSpPr>
-          <p:cNvPr id="15" name="leftC"/>
+              <a:t>11 / 12</a:t>
+            </a:r>
+          </a:p>
+        </p:txBody>
+      </p:sp>
+      <p:sp>
+        <p:nvSpPr>
+          <p:cNvPr id="15" name="card"/>
           <p:cNvSpPr/>
           <p:nvPr/>
         </p:nvSpPr>
         <p:spPr>
           <a:xfrm>
             <a:off x="480000" y="1120000"/>
-            <a:ext cx="4800000" cy="5000000"/>
+            <a:ext cx="11000000" cy="5000000"/>
           </a:xfrm>
           <a:prstGeom prst="roundRect">
             <a:avLst>
@@ -2108,48 +1957,20 @@
       </p:sp>
       <p:sp>
         <p:nvSpPr>
-          <p:cNvPr id="16" name="rightC"/>
-          <p:cNvSpPr/>
-          <p:nvPr/>
-        </p:nvSpPr>
-        <p:spPr>
-          <a:xfrm>
-            <a:off x="5400000" y="1120000"/>
-            <a:ext cx="6200000" cy="5000000"/>
+          <p:cNvPr id="16" name="cardB"/>
+          <p:cNvSpPr/>
+          <p:nvPr/>
+        </p:nvSpPr>
+        <p:spPr>
+          <a:xfrm>
+            <a:off x="480000" y="1120000"/>
+            <a:ext cx="11000000" cy="5000000"/>
           </a:xfrm>
           <a:prstGeom prst="roundRect">
             <a:avLst>
               <a:gd name="adj" fmla="val 8000"/>
             </a:avLst>
           </a:prstGeom>
-          <a:solidFill>
-            <a:srgbClr val="FFFFFF"/>
-          </a:solidFill>
-          <a:ln>
-            <a:noFill/>
-          </a:ln>
-        </p:spPr>
-        <p:txBody>
-          <a:bodyPr/>
-          <a:lstStyle/>
-        </p:txBody>
-      </p:sp>
-      <p:sp>
-        <p:nvSpPr>
-          <p:cNvPr id="21" name="rightB"/>
-          <p:cNvSpPr/>
-          <p:nvPr/>
-        </p:nvSpPr>
-        <p:spPr>
-          <a:xfrm>
-            <a:off x="5400000" y="1120000"/>
-            <a:ext cx="6200000" cy="5000000"/>
-          </a:xfrm>
-          <a:prstGeom prst="roundRect">
-            <a:avLst>
-              <a:gd name="adj" fmla="val 8000"/>
-            </a:avLst>
-          </a:prstGeom>
           <a:noFill/>
           <a:ln w="12700">
             <a:solidFill>
@@ -2170,7 +1991,7 @@
         </p:nvSpPr>
         <p:spPr>
           <a:xfrm>
-            <a:off x="560000" y="1040000"/>
+            <a:off x="600000" y="1040000"/>
             <a:ext cx="10500000" cy="380000"/>
           </a:xfrm>
           <a:prstGeom prst="rect">
@@ -2193,7 +2014,7 @@
                 </a:solidFill>
                 <a:latin typeface="Calibri Light"/>
               </a:rPr>
-              <a:t>Тестирование</a:t>
+              <a:t>Заключение</a:t>
             </a:r>
           </a:p>
         </p:txBody>
@@ -2206,8 +2027,8 @@
         </p:nvSpPr>
         <p:spPr>
           <a:xfrm>
-            <a:off x="600000" y="1200000"/>
-            <a:ext cx="4600000" cy="4800000"/>
+            <a:off x="680000" y="1200000"/>
+            <a:ext cx="10400000" cy="4900000"/>
           </a:xfrm>
           <a:prstGeom prst="rect">
             <a:avLst/>
@@ -2231,7 +2052,7 @@
                 </a:solidFill>
                 <a:latin typeface="Calibri"/>
               </a:rPr>
-              <a:t>Модульное, интеграционное, функциональное</a:t>
+              <a:t>Разработан модуль «AI Тур-Генератор» для ООО «Бон Вояж»</a:t>
             </a:r>
           </a:p>
           <a:p>
@@ -2245,157 +2066,49 @@
                 </a:solidFill>
                 <a:latin typeface="Calibri"/>
               </a:rPr>
-              <a:t>Все сценарии пройдены успешно</a:t>
-            </a:r>
-          </a:p>
-        </p:txBody>
-      </p:sp>
-      <p:sp>
-        <p:nvSpPr>
-          <p:cNvPr id="4" name="Detail"/>
-          <p:cNvSpPr/>
-          <p:nvPr/>
-        </p:nvSpPr>
-        <p:spPr>
-          <a:xfrm>
-            <a:off x="5520000" y="1180000"/>
-            <a:ext cx="6000000" cy="4900000"/>
-          </a:xfrm>
-          <a:prstGeom prst="rect">
-            <a:avLst/>
-          </a:prstGeom>
-          <a:noFill/>
-          <a:ln>
-            <a:noFill/>
-          </a:ln>
-        </p:spPr>
-        <p:txBody>
-          <a:bodyPr anchor="t" wrap="square" lIns="91440" tIns="45720" rIns="91440" bIns="45720"/>
-          <a:lstStyle/>
-          <a:p>
-            <a:pPr algn="l" spcAft="400"/>
-            <a:r>
-              <a:rPr sz="1500" b="1">
-                <a:solidFill>
-                  <a:srgbClr val="01773A"/>
-                </a:solidFill>
-                <a:latin typeface="Calibri"/>
-              </a:rPr>
-              <a:t>МОДУЛЬНОЕ</a:t>
-            </a:r>
-          </a:p>
-          <a:p>
-            <a:pPr algn="l" spcAft="100"/>
-            <a:r>
-              <a:rPr sz="1450">
-                <a:solidFill>
-                  <a:srgbClr val="1E293B"/>
-                </a:solidFill>
-                <a:latin typeface="Calibri"/>
-              </a:rPr>
-              <a:t>· test_dates.py — валидация дат поездки</a:t>
-            </a:r>
-          </a:p>
-          <a:p>
-            <a:pPr spcAft="200"/>
-          </a:p>
-          <a:p>
-            <a:pPr algn="l" spcAft="400"/>
-            <a:r>
-              <a:rPr sz="1500" b="1">
-                <a:solidFill>
-                  <a:srgbClr val="01773A"/>
-                </a:solidFill>
-                <a:latin typeface="Calibri"/>
-              </a:rPr>
-              <a:t>ИНТЕГРАЦИОННОЕ</a:t>
-            </a:r>
-          </a:p>
-          <a:p>
-            <a:pPr algn="l" spcAft="100"/>
-            <a:r>
-              <a:rPr sz="1450">
-                <a:solidFill>
-                  <a:srgbClr val="1E293B"/>
-                </a:solidFill>
-                <a:latin typeface="Calibri"/>
-              </a:rPr>
-              <a:t>· test_deepseek.py — API DeepSeek</a:t>
-            </a:r>
-          </a:p>
-          <a:p>
-            <a:pPr algn="l" spcAft="100"/>
-            <a:r>
-              <a:rPr sz="1450">
-                <a:solidFill>
-                  <a:srgbClr val="1E293B"/>
-                </a:solidFill>
-                <a:latin typeface="Calibri"/>
-              </a:rPr>
-              <a:t>· test_gigachat.py — API GigaChat</a:t>
-            </a:r>
-          </a:p>
-          <a:p>
-            <a:pPr spcAft="200"/>
-          </a:p>
-          <a:p>
-            <a:pPr algn="l" spcAft="400"/>
-            <a:r>
-              <a:rPr sz="1500" b="1">
-                <a:solidFill>
-                  <a:srgbClr val="01773A"/>
-                </a:solidFill>
-                <a:latin typeface="Calibri"/>
-              </a:rPr>
-              <a:t>ФУНКЦИОНАЛЬНОЕ</a:t>
-            </a:r>
-          </a:p>
-          <a:p>
-            <a:pPr algn="l" spcAft="100"/>
-            <a:r>
-              <a:rPr sz="1450">
-                <a:solidFill>
-                  <a:srgbClr val="1E293B"/>
-                </a:solidFill>
-                <a:latin typeface="Calibri"/>
-              </a:rPr>
-              <a:t>· Полный диалог → турпакет</a:t>
-            </a:r>
-          </a:p>
-          <a:p>
-            <a:pPr algn="l" spcAft="100"/>
-            <a:r>
-              <a:rPr sz="1450">
-                <a:solidFill>
-                  <a:srgbClr val="1E293B"/>
-                </a:solidFill>
-                <a:latin typeface="Calibri"/>
-              </a:rPr>
-              <a:t>· Fallback при сбое GigaChat</a:t>
-            </a:r>
-          </a:p>
-          <a:p>
-            <a:pPr algn="l" spcAft="100"/>
-            <a:r>
-              <a:rPr sz="1450">
-                <a:solidFill>
-                  <a:srgbClr val="1E293B"/>
-                </a:solidFill>
-                <a:latin typeface="Calibri"/>
-              </a:rPr>
-              <a:t>· Сброс сессии (POST /api/reset)</a:t>
-            </a:r>
-          </a:p>
-          <a:p>
-            <a:pPr algn="l" spcAft="100"/>
-            <a:r>
-              <a:rPr sz="1450">
-                <a:solidFill>
-                  <a:srgbClr val="1E293B"/>
-                </a:solidFill>
-                <a:latin typeface="Calibri"/>
-              </a:rPr>
-              <a:t>· Сохранение заявки в agency_leads</a:t>
+              <a:t>Реализованы диалог на русском, парсер каталога, двухфазный AI-агент</a:t>
+            </a:r>
+          </a:p>
+          <a:p>
+            <a:pPr marL="280000" indent="-140000" spcAft="700">
+              <a:buChar char="●"/>
+            </a:pPr>
+            <a:r>
+              <a:rPr sz="1620">
+                <a:solidFill>
+                  <a:srgbClr val="1E293B"/>
+                </a:solidFill>
+                <a:latin typeface="Calibri"/>
+              </a:rPr>
+              <a:t>Двухпровайдерная схема GigaChat + DeepSeek</a:t>
+            </a:r>
+          </a:p>
+          <a:p>
+            <a:pPr marL="280000" indent="-140000" spcAft="700">
+              <a:buChar char="●"/>
+            </a:pPr>
+            <a:r>
+              <a:rPr sz="1620">
+                <a:solidFill>
+                  <a:srgbClr val="1E293B"/>
+                </a:solidFill>
+                <a:latin typeface="Calibri"/>
+              </a:rPr>
+              <a:t>Цель достигнута, все задачи выполнены</a:t>
+            </a:r>
+          </a:p>
+          <a:p>
+            <a:pPr marL="280000" indent="-140000" spcAft="700">
+              <a:buChar char="●"/>
+            </a:pPr>
+            <a:r>
+              <a:rPr sz="1620">
+                <a:solidFill>
+                  <a:srgbClr val="1E293B"/>
+                </a:solidFill>
+                <a:latin typeface="Calibri"/>
+              </a:rPr>
+              <a:t>Модуль готов к внедрению на bon-voyage28.ru</a:t>
             </a:r>
           </a:p>
         </p:txBody>
@@ -2411,1523 +2124,6 @@
 <file path=ppt/slides/slide12.xml><?xml version="1.0" encoding="utf-8"?>
 <p:sld xmlns:a="http://schemas.openxmlformats.org/drawingml/2006/main" xmlns:r="http://schemas.openxmlformats.org/officeDocument/2006/relationships" xmlns:p="http://schemas.openxmlformats.org/presentationml/2006/main">
   <p:cSld name="Slide 12">
-    <p:bg>
-      <p:bgPr>
-        <a:solidFill>
-          <a:srgbClr val="FFFFFF"/>
-        </a:solidFill>
-        <a:effectLst/>
-      </p:bgPr>
-    </p:bg>
-    <p:spTree>
-      <p:nvGrpSpPr>
-        <p:cNvPr id="1" name=""/>
-        <p:cNvGrpSpPr/>
-        <p:nvPr/>
-      </p:nvGrpSpPr>
-      <p:grpSpPr>
-        <a:xfrm>
-          <a:off x="0" y="0"/>
-          <a:ext cx="0" cy="0"/>
-        </a:xfrm>
-      </p:grpSpPr>
-      <p:sp>
-        <p:nvSpPr>
-          <p:cNvPr id="10" name="hdr"/>
-          <p:cNvSpPr/>
-          <p:nvPr/>
-        </p:nvSpPr>
-        <p:spPr>
-          <a:xfrm>
-            <a:off x="0" y="0"/>
-            <a:ext cx="12192000" cy="500000"/>
-          </a:xfrm>
-          <a:prstGeom prst="rect">
-            <a:avLst/>
-          </a:prstGeom>
-          <a:solidFill>
-            <a:srgbClr val="01773A"/>
-          </a:solidFill>
-          <a:ln>
-            <a:noFill/>
-          </a:ln>
-        </p:spPr>
-        <p:txBody>
-          <a:bodyPr/>
-          <a:lstStyle/>
-        </p:txBody>
-      </p:sp>
-      <p:sp>
-        <p:nvSpPr>
-          <p:cNvPr id="11" name="hdr1"/>
-          <p:cNvSpPr/>
-          <p:nvPr/>
-        </p:nvSpPr>
-        <p:spPr>
-          <a:xfrm>
-            <a:off x="360000" y="100000"/>
-            <a:ext cx="5000000" cy="300000"/>
-          </a:xfrm>
-          <a:prstGeom prst="rect">
-            <a:avLst/>
-          </a:prstGeom>
-          <a:noFill/>
-          <a:ln>
-            <a:noFill/>
-          </a:ln>
-        </p:spPr>
-        <p:txBody>
-          <a:bodyPr anchor="t" wrap="square" lIns="91440" tIns="45720" rIns="91440" bIns="45720"/>
-          <a:lstStyle/>
-          <a:p>
-            <a:pPr algn="l"/>
-            <a:r>
-              <a:rPr sz="1500" b="1">
-                <a:solidFill>
-                  <a:srgbClr val="FFFFFF"/>
-                </a:solidFill>
-                <a:latin typeface="Calibri"/>
-              </a:rPr>
-              <a:t>✈  AI Тур-Генератор</a:t>
-            </a:r>
-          </a:p>
-        </p:txBody>
-      </p:sp>
-      <p:sp>
-        <p:nvSpPr>
-          <p:cNvPr id="12" name="hdr2"/>
-          <p:cNvSpPr/>
-          <p:nvPr/>
-        </p:nvSpPr>
-        <p:spPr>
-          <a:xfrm>
-            <a:off x="7400000" y="120000"/>
-            <a:ext cx="4400000" cy="260000"/>
-          </a:xfrm>
-          <a:prstGeom prst="rect">
-            <a:avLst/>
-          </a:prstGeom>
-          <a:noFill/>
-          <a:ln>
-            <a:noFill/>
-          </a:ln>
-        </p:spPr>
-        <p:txBody>
-          <a:bodyPr anchor="ctr" wrap="square" lIns="91440" tIns="45720" rIns="91440" bIns="45720"/>
-          <a:lstStyle/>
-          <a:p>
-            <a:pPr algn="r"/>
-            <a:r>
-              <a:rPr sz="1150">
-                <a:solidFill>
-                  <a:srgbClr val="BBF7D0"/>
-                </a:solidFill>
-                <a:latin typeface="Calibri"/>
-              </a:rPr>
-              <a:t>Защита диплома · 09.02.07</a:t>
-            </a:r>
-          </a:p>
-        </p:txBody>
-      </p:sp>
-      <p:sp>
-        <p:nvSpPr>
-          <p:cNvPr id="13" name="stripe"/>
-          <p:cNvSpPr/>
-          <p:nvPr/>
-        </p:nvSpPr>
-        <p:spPr>
-          <a:xfrm>
-            <a:off x="0" y="500000"/>
-            <a:ext cx="90000" cy="5800000"/>
-          </a:xfrm>
-          <a:prstGeom prst="rect">
-            <a:avLst/>
-          </a:prstGeom>
-          <a:solidFill>
-            <a:srgbClr val="028A46"/>
-          </a:solidFill>
-          <a:ln>
-            <a:noFill/>
-          </a:ln>
-        </p:spPr>
-        <p:txBody>
-          <a:bodyPr/>
-          <a:lstStyle/>
-        </p:txBody>
-      </p:sp>
-      <p:sp>
-        <p:nvSpPr>
-          <p:cNvPr id="17" name="ul"/>
-          <p:cNvSpPr/>
-          <p:nvPr/>
-        </p:nvSpPr>
-        <p:spPr>
-          <a:xfrm>
-            <a:off x="560000" y="1000000"/>
-            <a:ext cx="2800000" cy="40000"/>
-          </a:xfrm>
-          <a:prstGeom prst="rect">
-            <a:avLst/>
-          </a:prstGeom>
-          <a:solidFill>
-            <a:srgbClr val="01773A"/>
-          </a:solidFill>
-          <a:ln>
-            <a:noFill/>
-          </a:ln>
-        </p:spPr>
-        <p:txBody>
-          <a:bodyPr/>
-          <a:lstStyle/>
-        </p:txBody>
-      </p:sp>
-      <p:sp>
-        <p:nvSpPr>
-          <p:cNvPr id="18" name="ftr"/>
-          <p:cNvSpPr/>
-          <p:nvPr/>
-        </p:nvSpPr>
-        <p:spPr>
-          <a:xfrm>
-            <a:off x="0" y="6320000"/>
-            <a:ext cx="12192000" cy="538000"/>
-          </a:xfrm>
-          <a:prstGeom prst="rect">
-            <a:avLst/>
-          </a:prstGeom>
-          <a:solidFill>
-            <a:srgbClr val="1E293B"/>
-          </a:solidFill>
-          <a:ln>
-            <a:noFill/>
-          </a:ln>
-        </p:spPr>
-        <p:txBody>
-          <a:bodyPr/>
-          <a:lstStyle/>
-        </p:txBody>
-      </p:sp>
-      <p:sp>
-        <p:nvSpPr>
-          <p:cNvPr id="19" name="ftrL"/>
-          <p:cNvSpPr/>
-          <p:nvPr/>
-        </p:nvSpPr>
-        <p:spPr>
-          <a:xfrm>
-            <a:off x="360000" y="6390000"/>
-            <a:ext cx="5000000" cy="260000"/>
-          </a:xfrm>
-          <a:prstGeom prst="rect">
-            <a:avLst/>
-          </a:prstGeom>
-          <a:noFill/>
-          <a:ln>
-            <a:noFill/>
-          </a:ln>
-        </p:spPr>
-        <p:txBody>
-          <a:bodyPr anchor="t" wrap="square" lIns="91440" tIns="45720" rIns="91440" bIns="45720"/>
-          <a:lstStyle/>
-          <a:p>
-            <a:pPr algn="l"/>
-            <a:r>
-              <a:rPr sz="1100">
-                <a:solidFill>
-                  <a:srgbClr val="BBF7D0"/>
-                </a:solidFill>
-                <a:latin typeface="Calibri"/>
-              </a:rPr>
-              <a:t>bon-voyage28.ru · Планета 360</a:t>
-            </a:r>
-          </a:p>
-        </p:txBody>
-      </p:sp>
-      <p:sp>
-        <p:nvSpPr>
-          <p:cNvPr id="20" name="ftrR"/>
-          <p:cNvSpPr/>
-          <p:nvPr/>
-        </p:nvSpPr>
-        <p:spPr>
-          <a:xfrm>
-            <a:off x="9200000" y="6390000"/>
-            <a:ext cx="2400000" cy="260000"/>
-          </a:xfrm>
-          <a:prstGeom prst="rect">
-            <a:avLst/>
-          </a:prstGeom>
-          <a:noFill/>
-          <a:ln>
-            <a:noFill/>
-          </a:ln>
-        </p:spPr>
-        <p:txBody>
-          <a:bodyPr anchor="ctr" wrap="square" lIns="91440" tIns="45720" rIns="91440" bIns="45720"/>
-          <a:lstStyle/>
-          <a:p>
-            <a:pPr algn="r"/>
-            <a:r>
-              <a:rPr sz="1200" b="1">
-                <a:solidFill>
-                  <a:srgbClr val="FFFFFF"/>
-                </a:solidFill>
-                <a:latin typeface="Calibri"/>
-              </a:rPr>
-              <a:t>12 / 15</a:t>
-            </a:r>
-          </a:p>
-        </p:txBody>
-      </p:sp>
-      <p:sp>
-        <p:nvSpPr>
-          <p:cNvPr id="15" name="leftC"/>
-          <p:cNvSpPr/>
-          <p:nvPr/>
-        </p:nvSpPr>
-        <p:spPr>
-          <a:xfrm>
-            <a:off x="480000" y="1120000"/>
-            <a:ext cx="4800000" cy="5000000"/>
-          </a:xfrm>
-          <a:prstGeom prst="roundRect">
-            <a:avLst>
-              <a:gd name="adj" fmla="val 8000"/>
-            </a:avLst>
-          </a:prstGeom>
-          <a:solidFill>
-            <a:srgbClr val="F0FDF4"/>
-          </a:solidFill>
-          <a:ln>
-            <a:noFill/>
-          </a:ln>
-        </p:spPr>
-        <p:txBody>
-          <a:bodyPr/>
-          <a:lstStyle/>
-        </p:txBody>
-      </p:sp>
-      <p:sp>
-        <p:nvSpPr>
-          <p:cNvPr id="16" name="rightC"/>
-          <p:cNvSpPr/>
-          <p:nvPr/>
-        </p:nvSpPr>
-        <p:spPr>
-          <a:xfrm>
-            <a:off x="5400000" y="1120000"/>
-            <a:ext cx="6200000" cy="5000000"/>
-          </a:xfrm>
-          <a:prstGeom prst="roundRect">
-            <a:avLst>
-              <a:gd name="adj" fmla="val 8000"/>
-            </a:avLst>
-          </a:prstGeom>
-          <a:solidFill>
-            <a:srgbClr val="FFFFFF"/>
-          </a:solidFill>
-          <a:ln>
-            <a:noFill/>
-          </a:ln>
-        </p:spPr>
-        <p:txBody>
-          <a:bodyPr/>
-          <a:lstStyle/>
-        </p:txBody>
-      </p:sp>
-      <p:sp>
-        <p:nvSpPr>
-          <p:cNvPr id="21" name="rightB"/>
-          <p:cNvSpPr/>
-          <p:nvPr/>
-        </p:nvSpPr>
-        <p:spPr>
-          <a:xfrm>
-            <a:off x="5400000" y="1120000"/>
-            <a:ext cx="6200000" cy="5000000"/>
-          </a:xfrm>
-          <a:prstGeom prst="roundRect">
-            <a:avLst>
-              <a:gd name="adj" fmla="val 8000"/>
-            </a:avLst>
-          </a:prstGeom>
-          <a:noFill/>
-          <a:ln w="12700">
-            <a:solidFill>
-              <a:srgbClr val="BBF7D0"/>
-            </a:solidFill>
-          </a:ln>
-        </p:spPr>
-        <p:txBody>
-          <a:bodyPr/>
-          <a:lstStyle/>
-        </p:txBody>
-      </p:sp>
-      <p:sp>
-        <p:nvSpPr>
-          <p:cNvPr id="2" name="Title"/>
-          <p:cNvSpPr/>
-          <p:nvPr/>
-        </p:nvSpPr>
-        <p:spPr>
-          <a:xfrm>
-            <a:off x="560000" y="1040000"/>
-            <a:ext cx="10500000" cy="380000"/>
-          </a:xfrm>
-          <a:prstGeom prst="rect">
-            <a:avLst/>
-          </a:prstGeom>
-          <a:noFill/>
-          <a:ln>
-            <a:noFill/>
-          </a:ln>
-        </p:spPr>
-        <p:txBody>
-          <a:bodyPr anchor="t" wrap="square" lIns="91440" tIns="45720" rIns="91440" bIns="45720"/>
-          <a:lstStyle/>
-          <a:p>
-            <a:pPr algn="l"/>
-            <a:r>
-              <a:rPr sz="2400" b="1">
-                <a:solidFill>
-                  <a:srgbClr val="01773A"/>
-                </a:solidFill>
-                <a:latin typeface="Calibri Light"/>
-              </a:rPr>
-              <a:t>Экономическое обоснование</a:t>
-            </a:r>
-          </a:p>
-        </p:txBody>
-      </p:sp>
-      <p:sp>
-        <p:nvSpPr>
-          <p:cNvPr id="3" name="Body"/>
-          <p:cNvSpPr/>
-          <p:nvPr/>
-        </p:nvSpPr>
-        <p:spPr>
-          <a:xfrm>
-            <a:off x="600000" y="1200000"/>
-            <a:ext cx="4600000" cy="4800000"/>
-          </a:xfrm>
-          <a:prstGeom prst="rect">
-            <a:avLst/>
-          </a:prstGeom>
-          <a:noFill/>
-          <a:ln>
-            <a:noFill/>
-          </a:ln>
-        </p:spPr>
-        <p:txBody>
-          <a:bodyPr anchor="t" wrap="square" lIns="91440" tIns="45720" rIns="91440" bIns="45720"/>
-          <a:lstStyle/>
-          <a:p>
-            <a:pPr marL="280000" indent="-140000" spcAft="700">
-              <a:buChar char="●"/>
-            </a:pPr>
-            <a:r>
-              <a:rPr sz="1620">
-                <a:solidFill>
-                  <a:srgbClr val="1E293B"/>
-                </a:solidFill>
-                <a:latin typeface="Calibri"/>
-              </a:rPr>
-              <a:t>Затраты на разработку: 107 720 руб.</a:t>
-            </a:r>
-          </a:p>
-          <a:p>
-            <a:pPr marL="280000" indent="-140000" spcAft="700">
-              <a:buChar char="●"/>
-            </a:pPr>
-            <a:r>
-              <a:rPr sz="1620">
-                <a:solidFill>
-                  <a:srgbClr val="1E293B"/>
-                </a:solidFill>
-                <a:latin typeface="Calibri"/>
-              </a:rPr>
-              <a:t>Эксплуатация: 47 100 руб./год</a:t>
-            </a:r>
-          </a:p>
-          <a:p>
-            <a:pPr marL="280000" indent="-140000" spcAft="700">
-              <a:buChar char="●"/>
-            </a:pPr>
-            <a:r>
-              <a:rPr sz="1620">
-                <a:solidFill>
-                  <a:srgbClr val="1E293B"/>
-                </a:solidFill>
-                <a:latin typeface="Calibri"/>
-              </a:rPr>
-              <a:t>Чистый эффект: 711 300 руб./год</a:t>
-            </a:r>
-          </a:p>
-        </p:txBody>
-      </p:sp>
-      <p:sp>
-        <p:nvSpPr>
-          <p:cNvPr id="4" name="Detail"/>
-          <p:cNvSpPr/>
-          <p:nvPr/>
-        </p:nvSpPr>
-        <p:spPr>
-          <a:xfrm>
-            <a:off x="5520000" y="1180000"/>
-            <a:ext cx="6000000" cy="4900000"/>
-          </a:xfrm>
-          <a:prstGeom prst="rect">
-            <a:avLst/>
-          </a:prstGeom>
-          <a:noFill/>
-          <a:ln>
-            <a:noFill/>
-          </a:ln>
-        </p:spPr>
-        <p:txBody>
-          <a:bodyPr anchor="t" wrap="square" lIns="91440" tIns="45720" rIns="91440" bIns="45720"/>
-          <a:lstStyle/>
-          <a:p>
-            <a:pPr algn="l" spcAft="400"/>
-            <a:r>
-              <a:rPr sz="1500" b="1">
-                <a:solidFill>
-                  <a:srgbClr val="01773A"/>
-                </a:solidFill>
-                <a:latin typeface="Calibri"/>
-              </a:rPr>
-              <a:t>ЗАТРАТЫ НА РАЗРАБОТКУ</a:t>
-            </a:r>
-          </a:p>
-          <a:p>
-            <a:pPr algn="l" spcAft="100"/>
-            <a:r>
-              <a:rPr sz="1450">
-                <a:solidFill>
-                  <a:srgbClr val="1E293B"/>
-                </a:solidFill>
-                <a:latin typeface="Calibri"/>
-              </a:rPr>
-              <a:t>· 200 ч × 500 руб./ч = 100 000 руб.</a:t>
-            </a:r>
-          </a:p>
-          <a:p>
-            <a:pPr algn="l" spcAft="100"/>
-            <a:r>
-              <a:rPr sz="1450">
-                <a:solidFill>
-                  <a:srgbClr val="1E293B"/>
-                </a:solidFill>
-                <a:latin typeface="Calibri"/>
-              </a:rPr>
-              <a:t>· Материалы и хостинг = 7 720 руб.</a:t>
-            </a:r>
-          </a:p>
-          <a:p>
-            <a:pPr algn="l" spcAft="100"/>
-            <a:r>
-              <a:rPr sz="1450">
-                <a:solidFill>
-                  <a:srgbClr val="1E293B"/>
-                </a:solidFill>
-                <a:latin typeface="Calibri"/>
-              </a:rPr>
-              <a:t>· Итого: 107 720 руб.</a:t>
-            </a:r>
-          </a:p>
-          <a:p>
-            <a:pPr spcAft="200"/>
-          </a:p>
-          <a:p>
-            <a:pPr algn="l" spcAft="400"/>
-            <a:r>
-              <a:rPr sz="1500" b="1">
-                <a:solidFill>
-                  <a:srgbClr val="01773A"/>
-                </a:solidFill>
-                <a:latin typeface="Calibri"/>
-              </a:rPr>
-              <a:t>ЭФФЕКТ В ГОД</a:t>
-            </a:r>
-          </a:p>
-          <a:p>
-            <a:pPr algn="l" spcAft="100"/>
-            <a:r>
-              <a:rPr sz="1450">
-                <a:solidFill>
-                  <a:srgbClr val="1E293B"/>
-                </a:solidFill>
-                <a:latin typeface="Calibri"/>
-              </a:rPr>
-              <a:t>· Экономия времени менеджеров</a:t>
-            </a:r>
-          </a:p>
-          <a:p>
-            <a:pPr algn="l" spcAft="100"/>
-            <a:r>
-              <a:rPr sz="1450">
-                <a:solidFill>
-                  <a:srgbClr val="1E293B"/>
-                </a:solidFill>
-                <a:latin typeface="Calibri"/>
-              </a:rPr>
-              <a:t>· Дополнительные заявки с сайта</a:t>
-            </a:r>
-          </a:p>
-          <a:p>
-            <a:pPr algn="l" spcAft="100"/>
-            <a:r>
-              <a:rPr sz="1450">
-                <a:solidFill>
-                  <a:srgbClr val="1E293B"/>
-                </a:solidFill>
-                <a:latin typeface="Calibri"/>
-              </a:rPr>
-              <a:t>· Чистый эффект: 711 300 руб./год</a:t>
-            </a:r>
-          </a:p>
-          <a:p>
-            <a:pPr spcAft="200"/>
-          </a:p>
-          <a:p>
-            <a:pPr algn="l" spcAft="120"/>
-            <a:r>
-              <a:rPr sz="1450">
-                <a:solidFill>
-                  <a:srgbClr val="1E293B"/>
-                </a:solidFill>
-                <a:latin typeface="Calibri"/>
-              </a:rPr>
-              <a:t>Окупаемость: ~2 месяца</a:t>
-            </a:r>
-          </a:p>
-          <a:p>
-            <a:pPr algn="l" spcAft="120"/>
-            <a:r>
-              <a:rPr sz="1450">
-                <a:solidFill>
-                  <a:srgbClr val="1E293B"/>
-                </a:solidFill>
-                <a:latin typeface="Calibri"/>
-              </a:rPr>
-              <a:t>Коэффициент эффективности Kэф = 6,6</a:t>
-            </a:r>
-          </a:p>
-        </p:txBody>
-      </p:sp>
-    </p:spTree>
-  </p:cSld>
-  <p:clrMapOvr>
-    <a:masterClrMapping/>
-  </p:clrMapOvr>
-</p:sld>
-</file>
-
-<file path=ppt/slides/slide13.xml><?xml version="1.0" encoding="utf-8"?>
-<p:sld xmlns:a="http://schemas.openxmlformats.org/drawingml/2006/main" xmlns:r="http://schemas.openxmlformats.org/officeDocument/2006/relationships" xmlns:p="http://schemas.openxmlformats.org/presentationml/2006/main">
-  <p:cSld name="Slide 13">
-    <p:bg>
-      <p:bgPr>
-        <a:solidFill>
-          <a:srgbClr val="FFFFFF"/>
-        </a:solidFill>
-        <a:effectLst/>
-      </p:bgPr>
-    </p:bg>
-    <p:spTree>
-      <p:nvGrpSpPr>
-        <p:cNvPr id="1" name=""/>
-        <p:cNvGrpSpPr/>
-        <p:nvPr/>
-      </p:nvGrpSpPr>
-      <p:grpSpPr>
-        <a:xfrm>
-          <a:off x="0" y="0"/>
-          <a:ext cx="0" cy="0"/>
-        </a:xfrm>
-      </p:grpSpPr>
-      <p:sp>
-        <p:nvSpPr>
-          <p:cNvPr id="10" name="hdr"/>
-          <p:cNvSpPr/>
-          <p:nvPr/>
-        </p:nvSpPr>
-        <p:spPr>
-          <a:xfrm>
-            <a:off x="0" y="0"/>
-            <a:ext cx="12192000" cy="500000"/>
-          </a:xfrm>
-          <a:prstGeom prst="rect">
-            <a:avLst/>
-          </a:prstGeom>
-          <a:solidFill>
-            <a:srgbClr val="01773A"/>
-          </a:solidFill>
-          <a:ln>
-            <a:noFill/>
-          </a:ln>
-        </p:spPr>
-        <p:txBody>
-          <a:bodyPr/>
-          <a:lstStyle/>
-        </p:txBody>
-      </p:sp>
-      <p:sp>
-        <p:nvSpPr>
-          <p:cNvPr id="11" name="hdr1"/>
-          <p:cNvSpPr/>
-          <p:nvPr/>
-        </p:nvSpPr>
-        <p:spPr>
-          <a:xfrm>
-            <a:off x="360000" y="100000"/>
-            <a:ext cx="5000000" cy="300000"/>
-          </a:xfrm>
-          <a:prstGeom prst="rect">
-            <a:avLst/>
-          </a:prstGeom>
-          <a:noFill/>
-          <a:ln>
-            <a:noFill/>
-          </a:ln>
-        </p:spPr>
-        <p:txBody>
-          <a:bodyPr anchor="t" wrap="square" lIns="91440" tIns="45720" rIns="91440" bIns="45720"/>
-          <a:lstStyle/>
-          <a:p>
-            <a:pPr algn="l"/>
-            <a:r>
-              <a:rPr sz="1500" b="1">
-                <a:solidFill>
-                  <a:srgbClr val="FFFFFF"/>
-                </a:solidFill>
-                <a:latin typeface="Calibri"/>
-              </a:rPr>
-              <a:t>✈  AI Тур-Генератор</a:t>
-            </a:r>
-          </a:p>
-        </p:txBody>
-      </p:sp>
-      <p:sp>
-        <p:nvSpPr>
-          <p:cNvPr id="12" name="hdr2"/>
-          <p:cNvSpPr/>
-          <p:nvPr/>
-        </p:nvSpPr>
-        <p:spPr>
-          <a:xfrm>
-            <a:off x="7400000" y="120000"/>
-            <a:ext cx="4400000" cy="260000"/>
-          </a:xfrm>
-          <a:prstGeom prst="rect">
-            <a:avLst/>
-          </a:prstGeom>
-          <a:noFill/>
-          <a:ln>
-            <a:noFill/>
-          </a:ln>
-        </p:spPr>
-        <p:txBody>
-          <a:bodyPr anchor="ctr" wrap="square" lIns="91440" tIns="45720" rIns="91440" bIns="45720"/>
-          <a:lstStyle/>
-          <a:p>
-            <a:pPr algn="r"/>
-            <a:r>
-              <a:rPr sz="1150">
-                <a:solidFill>
-                  <a:srgbClr val="BBF7D0"/>
-                </a:solidFill>
-                <a:latin typeface="Calibri"/>
-              </a:rPr>
-              <a:t>Защита диплома · 09.02.07</a:t>
-            </a:r>
-          </a:p>
-        </p:txBody>
-      </p:sp>
-      <p:sp>
-        <p:nvSpPr>
-          <p:cNvPr id="13" name="stripe"/>
-          <p:cNvSpPr/>
-          <p:nvPr/>
-        </p:nvSpPr>
-        <p:spPr>
-          <a:xfrm>
-            <a:off x="0" y="500000"/>
-            <a:ext cx="90000" cy="5800000"/>
-          </a:xfrm>
-          <a:prstGeom prst="rect">
-            <a:avLst/>
-          </a:prstGeom>
-          <a:solidFill>
-            <a:srgbClr val="028A46"/>
-          </a:solidFill>
-          <a:ln>
-            <a:noFill/>
-          </a:ln>
-        </p:spPr>
-        <p:txBody>
-          <a:bodyPr/>
-          <a:lstStyle/>
-        </p:txBody>
-      </p:sp>
-      <p:sp>
-        <p:nvSpPr>
-          <p:cNvPr id="17" name="ul"/>
-          <p:cNvSpPr/>
-          <p:nvPr/>
-        </p:nvSpPr>
-        <p:spPr>
-          <a:xfrm>
-            <a:off x="560000" y="1000000"/>
-            <a:ext cx="2800000" cy="40000"/>
-          </a:xfrm>
-          <a:prstGeom prst="rect">
-            <a:avLst/>
-          </a:prstGeom>
-          <a:solidFill>
-            <a:srgbClr val="01773A"/>
-          </a:solidFill>
-          <a:ln>
-            <a:noFill/>
-          </a:ln>
-        </p:spPr>
-        <p:txBody>
-          <a:bodyPr/>
-          <a:lstStyle/>
-        </p:txBody>
-      </p:sp>
-      <p:sp>
-        <p:nvSpPr>
-          <p:cNvPr id="18" name="ftr"/>
-          <p:cNvSpPr/>
-          <p:nvPr/>
-        </p:nvSpPr>
-        <p:spPr>
-          <a:xfrm>
-            <a:off x="0" y="6320000"/>
-            <a:ext cx="12192000" cy="538000"/>
-          </a:xfrm>
-          <a:prstGeom prst="rect">
-            <a:avLst/>
-          </a:prstGeom>
-          <a:solidFill>
-            <a:srgbClr val="1E293B"/>
-          </a:solidFill>
-          <a:ln>
-            <a:noFill/>
-          </a:ln>
-        </p:spPr>
-        <p:txBody>
-          <a:bodyPr/>
-          <a:lstStyle/>
-        </p:txBody>
-      </p:sp>
-      <p:sp>
-        <p:nvSpPr>
-          <p:cNvPr id="19" name="ftrL"/>
-          <p:cNvSpPr/>
-          <p:nvPr/>
-        </p:nvSpPr>
-        <p:spPr>
-          <a:xfrm>
-            <a:off x="360000" y="6390000"/>
-            <a:ext cx="5000000" cy="260000"/>
-          </a:xfrm>
-          <a:prstGeom prst="rect">
-            <a:avLst/>
-          </a:prstGeom>
-          <a:noFill/>
-          <a:ln>
-            <a:noFill/>
-          </a:ln>
-        </p:spPr>
-        <p:txBody>
-          <a:bodyPr anchor="t" wrap="square" lIns="91440" tIns="45720" rIns="91440" bIns="45720"/>
-          <a:lstStyle/>
-          <a:p>
-            <a:pPr algn="l"/>
-            <a:r>
-              <a:rPr sz="1100">
-                <a:solidFill>
-                  <a:srgbClr val="BBF7D0"/>
-                </a:solidFill>
-                <a:latin typeface="Calibri"/>
-              </a:rPr>
-              <a:t>bon-voyage28.ru · Планета 360</a:t>
-            </a:r>
-          </a:p>
-        </p:txBody>
-      </p:sp>
-      <p:sp>
-        <p:nvSpPr>
-          <p:cNvPr id="20" name="ftrR"/>
-          <p:cNvSpPr/>
-          <p:nvPr/>
-        </p:nvSpPr>
-        <p:spPr>
-          <a:xfrm>
-            <a:off x="9200000" y="6390000"/>
-            <a:ext cx="2400000" cy="260000"/>
-          </a:xfrm>
-          <a:prstGeom prst="rect">
-            <a:avLst/>
-          </a:prstGeom>
-          <a:noFill/>
-          <a:ln>
-            <a:noFill/>
-          </a:ln>
-        </p:spPr>
-        <p:txBody>
-          <a:bodyPr anchor="ctr" wrap="square" lIns="91440" tIns="45720" rIns="91440" bIns="45720"/>
-          <a:lstStyle/>
-          <a:p>
-            <a:pPr algn="r"/>
-            <a:r>
-              <a:rPr sz="1200" b="1">
-                <a:solidFill>
-                  <a:srgbClr val="FFFFFF"/>
-                </a:solidFill>
-                <a:latin typeface="Calibri"/>
-              </a:rPr>
-              <a:t>13 / 15</a:t>
-            </a:r>
-          </a:p>
-        </p:txBody>
-      </p:sp>
-      <p:sp>
-        <p:nvSpPr>
-          <p:cNvPr id="15" name="card"/>
-          <p:cNvSpPr/>
-          <p:nvPr/>
-        </p:nvSpPr>
-        <p:spPr>
-          <a:xfrm>
-            <a:off x="480000" y="1120000"/>
-            <a:ext cx="11000000" cy="5000000"/>
-          </a:xfrm>
-          <a:prstGeom prst="roundRect">
-            <a:avLst>
-              <a:gd name="adj" fmla="val 8000"/>
-            </a:avLst>
-          </a:prstGeom>
-          <a:solidFill>
-            <a:srgbClr val="F0FDF4"/>
-          </a:solidFill>
-          <a:ln>
-            <a:noFill/>
-          </a:ln>
-        </p:spPr>
-        <p:txBody>
-          <a:bodyPr/>
-          <a:lstStyle/>
-        </p:txBody>
-      </p:sp>
-      <p:sp>
-        <p:nvSpPr>
-          <p:cNvPr id="16" name="cardB"/>
-          <p:cNvSpPr/>
-          <p:nvPr/>
-        </p:nvSpPr>
-        <p:spPr>
-          <a:xfrm>
-            <a:off x="480000" y="1120000"/>
-            <a:ext cx="11000000" cy="5000000"/>
-          </a:xfrm>
-          <a:prstGeom prst="roundRect">
-            <a:avLst>
-              <a:gd name="adj" fmla="val 8000"/>
-            </a:avLst>
-          </a:prstGeom>
-          <a:noFill/>
-          <a:ln w="12700">
-            <a:solidFill>
-              <a:srgbClr val="BBF7D0"/>
-            </a:solidFill>
-          </a:ln>
-        </p:spPr>
-        <p:txBody>
-          <a:bodyPr/>
-          <a:lstStyle/>
-        </p:txBody>
-      </p:sp>
-      <p:sp>
-        <p:nvSpPr>
-          <p:cNvPr id="2" name="Title"/>
-          <p:cNvSpPr/>
-          <p:nvPr/>
-        </p:nvSpPr>
-        <p:spPr>
-          <a:xfrm>
-            <a:off x="600000" y="1040000"/>
-            <a:ext cx="10500000" cy="380000"/>
-          </a:xfrm>
-          <a:prstGeom prst="rect">
-            <a:avLst/>
-          </a:prstGeom>
-          <a:noFill/>
-          <a:ln>
-            <a:noFill/>
-          </a:ln>
-        </p:spPr>
-        <p:txBody>
-          <a:bodyPr anchor="t" wrap="square" lIns="91440" tIns="45720" rIns="91440" bIns="45720"/>
-          <a:lstStyle/>
-          <a:p>
-            <a:pPr algn="l"/>
-            <a:r>
-              <a:rPr sz="2400" b="1">
-                <a:solidFill>
-                  <a:srgbClr val="01773A"/>
-                </a:solidFill>
-                <a:latin typeface="Calibri Light"/>
-              </a:rPr>
-              <a:t>Результаты работы</a:t>
-            </a:r>
-          </a:p>
-        </p:txBody>
-      </p:sp>
-      <p:sp>
-        <p:nvSpPr>
-          <p:cNvPr id="3" name="Body"/>
-          <p:cNvSpPr/>
-          <p:nvPr/>
-        </p:nvSpPr>
-        <p:spPr>
-          <a:xfrm>
-            <a:off x="680000" y="1200000"/>
-            <a:ext cx="10400000" cy="4900000"/>
-          </a:xfrm>
-          <a:prstGeom prst="rect">
-            <a:avLst/>
-          </a:prstGeom>
-          <a:noFill/>
-          <a:ln>
-            <a:noFill/>
-          </a:ln>
-        </p:spPr>
-        <p:txBody>
-          <a:bodyPr anchor="t" wrap="square" lIns="91440" tIns="45720" rIns="91440" bIns="45720"/>
-          <a:lstStyle/>
-          <a:p>
-            <a:pPr marL="280000" indent="-140000" spcAft="700">
-              <a:buChar char="●"/>
-            </a:pPr>
-            <a:r>
-              <a:rPr sz="1620">
-                <a:solidFill>
-                  <a:srgbClr val="1E293B"/>
-                </a:solidFill>
-                <a:latin typeface="Calibri"/>
-              </a:rPr>
-              <a:t>Разработан модуль «AI Тур-Генератор»</a:t>
-            </a:r>
-          </a:p>
-          <a:p>
-            <a:pPr marL="280000" indent="-140000" spcAft="700">
-              <a:buChar char="●"/>
-            </a:pPr>
-            <a:r>
-              <a:rPr sz="1620">
-                <a:solidFill>
-                  <a:srgbClr val="1E293B"/>
-                </a:solidFill>
-                <a:latin typeface="Calibri"/>
-              </a:rPr>
-              <a:t>Диалог на русском, реальный каталог</a:t>
-            </a:r>
-          </a:p>
-          <a:p>
-            <a:pPr marL="280000" indent="-140000" spcAft="700">
-              <a:buChar char="●"/>
-            </a:pPr>
-            <a:r>
-              <a:rPr sz="1620">
-                <a:solidFill>
-                  <a:srgbClr val="1E293B"/>
-                </a:solidFill>
-                <a:latin typeface="Calibri"/>
-              </a:rPr>
-              <a:t>Двухпровайдерная схема ИИ</a:t>
-            </a:r>
-          </a:p>
-          <a:p>
-            <a:pPr marL="280000" indent="-140000" spcAft="700">
-              <a:buChar char="●"/>
-            </a:pPr>
-            <a:r>
-              <a:rPr sz="1620">
-                <a:solidFill>
-                  <a:srgbClr val="1E293B"/>
-                </a:solidFill>
-                <a:latin typeface="Calibri"/>
-              </a:rPr>
-              <a:t>Готов к внедрению на bon-voyage28.ru</a:t>
-            </a:r>
-          </a:p>
-        </p:txBody>
-      </p:sp>
-    </p:spTree>
-  </p:cSld>
-  <p:clrMapOvr>
-    <a:masterClrMapping/>
-  </p:clrMapOvr>
-</p:sld>
-</file>
-
-<file path=ppt/slides/slide14.xml><?xml version="1.0" encoding="utf-8"?>
-<p:sld xmlns:a="http://schemas.openxmlformats.org/drawingml/2006/main" xmlns:r="http://schemas.openxmlformats.org/officeDocument/2006/relationships" xmlns:p="http://schemas.openxmlformats.org/presentationml/2006/main">
-  <p:cSld name="Slide 14">
-    <p:bg>
-      <p:bgPr>
-        <a:solidFill>
-          <a:srgbClr val="FFFFFF"/>
-        </a:solidFill>
-        <a:effectLst/>
-      </p:bgPr>
-    </p:bg>
-    <p:spTree>
-      <p:nvGrpSpPr>
-        <p:cNvPr id="1" name=""/>
-        <p:cNvGrpSpPr/>
-        <p:nvPr/>
-      </p:nvGrpSpPr>
-      <p:grpSpPr>
-        <a:xfrm>
-          <a:off x="0" y="0"/>
-          <a:ext cx="0" cy="0"/>
-        </a:xfrm>
-      </p:grpSpPr>
-      <p:sp>
-        <p:nvSpPr>
-          <p:cNvPr id="10" name="hdr"/>
-          <p:cNvSpPr/>
-          <p:nvPr/>
-        </p:nvSpPr>
-        <p:spPr>
-          <a:xfrm>
-            <a:off x="0" y="0"/>
-            <a:ext cx="12192000" cy="500000"/>
-          </a:xfrm>
-          <a:prstGeom prst="rect">
-            <a:avLst/>
-          </a:prstGeom>
-          <a:solidFill>
-            <a:srgbClr val="01773A"/>
-          </a:solidFill>
-          <a:ln>
-            <a:noFill/>
-          </a:ln>
-        </p:spPr>
-        <p:txBody>
-          <a:bodyPr/>
-          <a:lstStyle/>
-        </p:txBody>
-      </p:sp>
-      <p:sp>
-        <p:nvSpPr>
-          <p:cNvPr id="11" name="hdr1"/>
-          <p:cNvSpPr/>
-          <p:nvPr/>
-        </p:nvSpPr>
-        <p:spPr>
-          <a:xfrm>
-            <a:off x="360000" y="100000"/>
-            <a:ext cx="5000000" cy="300000"/>
-          </a:xfrm>
-          <a:prstGeom prst="rect">
-            <a:avLst/>
-          </a:prstGeom>
-          <a:noFill/>
-          <a:ln>
-            <a:noFill/>
-          </a:ln>
-        </p:spPr>
-        <p:txBody>
-          <a:bodyPr anchor="t" wrap="square" lIns="91440" tIns="45720" rIns="91440" bIns="45720"/>
-          <a:lstStyle/>
-          <a:p>
-            <a:pPr algn="l"/>
-            <a:r>
-              <a:rPr sz="1500" b="1">
-                <a:solidFill>
-                  <a:srgbClr val="FFFFFF"/>
-                </a:solidFill>
-                <a:latin typeface="Calibri"/>
-              </a:rPr>
-              <a:t>✈  AI Тур-Генератор</a:t>
-            </a:r>
-          </a:p>
-        </p:txBody>
-      </p:sp>
-      <p:sp>
-        <p:nvSpPr>
-          <p:cNvPr id="12" name="hdr2"/>
-          <p:cNvSpPr/>
-          <p:nvPr/>
-        </p:nvSpPr>
-        <p:spPr>
-          <a:xfrm>
-            <a:off x="7400000" y="120000"/>
-            <a:ext cx="4400000" cy="260000"/>
-          </a:xfrm>
-          <a:prstGeom prst="rect">
-            <a:avLst/>
-          </a:prstGeom>
-          <a:noFill/>
-          <a:ln>
-            <a:noFill/>
-          </a:ln>
-        </p:spPr>
-        <p:txBody>
-          <a:bodyPr anchor="ctr" wrap="square" lIns="91440" tIns="45720" rIns="91440" bIns="45720"/>
-          <a:lstStyle/>
-          <a:p>
-            <a:pPr algn="r"/>
-            <a:r>
-              <a:rPr sz="1150">
-                <a:solidFill>
-                  <a:srgbClr val="BBF7D0"/>
-                </a:solidFill>
-                <a:latin typeface="Calibri"/>
-              </a:rPr>
-              <a:t>Защита диплома · 09.02.07</a:t>
-            </a:r>
-          </a:p>
-        </p:txBody>
-      </p:sp>
-      <p:sp>
-        <p:nvSpPr>
-          <p:cNvPr id="13" name="stripe"/>
-          <p:cNvSpPr/>
-          <p:nvPr/>
-        </p:nvSpPr>
-        <p:spPr>
-          <a:xfrm>
-            <a:off x="0" y="500000"/>
-            <a:ext cx="90000" cy="5800000"/>
-          </a:xfrm>
-          <a:prstGeom prst="rect">
-            <a:avLst/>
-          </a:prstGeom>
-          <a:solidFill>
-            <a:srgbClr val="028A46"/>
-          </a:solidFill>
-          <a:ln>
-            <a:noFill/>
-          </a:ln>
-        </p:spPr>
-        <p:txBody>
-          <a:bodyPr/>
-          <a:lstStyle/>
-        </p:txBody>
-      </p:sp>
-      <p:sp>
-        <p:nvSpPr>
-          <p:cNvPr id="17" name="ul"/>
-          <p:cNvSpPr/>
-          <p:nvPr/>
-        </p:nvSpPr>
-        <p:spPr>
-          <a:xfrm>
-            <a:off x="560000" y="1000000"/>
-            <a:ext cx="2800000" cy="40000"/>
-          </a:xfrm>
-          <a:prstGeom prst="rect">
-            <a:avLst/>
-          </a:prstGeom>
-          <a:solidFill>
-            <a:srgbClr val="01773A"/>
-          </a:solidFill>
-          <a:ln>
-            <a:noFill/>
-          </a:ln>
-        </p:spPr>
-        <p:txBody>
-          <a:bodyPr/>
-          <a:lstStyle/>
-        </p:txBody>
-      </p:sp>
-      <p:sp>
-        <p:nvSpPr>
-          <p:cNvPr id="18" name="ftr"/>
-          <p:cNvSpPr/>
-          <p:nvPr/>
-        </p:nvSpPr>
-        <p:spPr>
-          <a:xfrm>
-            <a:off x="0" y="6320000"/>
-            <a:ext cx="12192000" cy="538000"/>
-          </a:xfrm>
-          <a:prstGeom prst="rect">
-            <a:avLst/>
-          </a:prstGeom>
-          <a:solidFill>
-            <a:srgbClr val="1E293B"/>
-          </a:solidFill>
-          <a:ln>
-            <a:noFill/>
-          </a:ln>
-        </p:spPr>
-        <p:txBody>
-          <a:bodyPr/>
-          <a:lstStyle/>
-        </p:txBody>
-      </p:sp>
-      <p:sp>
-        <p:nvSpPr>
-          <p:cNvPr id="19" name="ftrL"/>
-          <p:cNvSpPr/>
-          <p:nvPr/>
-        </p:nvSpPr>
-        <p:spPr>
-          <a:xfrm>
-            <a:off x="360000" y="6390000"/>
-            <a:ext cx="5000000" cy="260000"/>
-          </a:xfrm>
-          <a:prstGeom prst="rect">
-            <a:avLst/>
-          </a:prstGeom>
-          <a:noFill/>
-          <a:ln>
-            <a:noFill/>
-          </a:ln>
-        </p:spPr>
-        <p:txBody>
-          <a:bodyPr anchor="t" wrap="square" lIns="91440" tIns="45720" rIns="91440" bIns="45720"/>
-          <a:lstStyle/>
-          <a:p>
-            <a:pPr algn="l"/>
-            <a:r>
-              <a:rPr sz="1100">
-                <a:solidFill>
-                  <a:srgbClr val="BBF7D0"/>
-                </a:solidFill>
-                <a:latin typeface="Calibri"/>
-              </a:rPr>
-              <a:t>bon-voyage28.ru · Планета 360</a:t>
-            </a:r>
-          </a:p>
-        </p:txBody>
-      </p:sp>
-      <p:sp>
-        <p:nvSpPr>
-          <p:cNvPr id="20" name="ftrR"/>
-          <p:cNvSpPr/>
-          <p:nvPr/>
-        </p:nvSpPr>
-        <p:spPr>
-          <a:xfrm>
-            <a:off x="9200000" y="6390000"/>
-            <a:ext cx="2400000" cy="260000"/>
-          </a:xfrm>
-          <a:prstGeom prst="rect">
-            <a:avLst/>
-          </a:prstGeom>
-          <a:noFill/>
-          <a:ln>
-            <a:noFill/>
-          </a:ln>
-        </p:spPr>
-        <p:txBody>
-          <a:bodyPr anchor="ctr" wrap="square" lIns="91440" tIns="45720" rIns="91440" bIns="45720"/>
-          <a:lstStyle/>
-          <a:p>
-            <a:pPr algn="r"/>
-            <a:r>
-              <a:rPr sz="1200" b="1">
-                <a:solidFill>
-                  <a:srgbClr val="FFFFFF"/>
-                </a:solidFill>
-                <a:latin typeface="Calibri"/>
-              </a:rPr>
-              <a:t>14 / 15</a:t>
-            </a:r>
-          </a:p>
-        </p:txBody>
-      </p:sp>
-      <p:sp>
-        <p:nvSpPr>
-          <p:cNvPr id="15" name="card"/>
-          <p:cNvSpPr/>
-          <p:nvPr/>
-        </p:nvSpPr>
-        <p:spPr>
-          <a:xfrm>
-            <a:off x="480000" y="1120000"/>
-            <a:ext cx="11000000" cy="5000000"/>
-          </a:xfrm>
-          <a:prstGeom prst="roundRect">
-            <a:avLst>
-              <a:gd name="adj" fmla="val 8000"/>
-            </a:avLst>
-          </a:prstGeom>
-          <a:solidFill>
-            <a:srgbClr val="F0FDF4"/>
-          </a:solidFill>
-          <a:ln>
-            <a:noFill/>
-          </a:ln>
-        </p:spPr>
-        <p:txBody>
-          <a:bodyPr/>
-          <a:lstStyle/>
-        </p:txBody>
-      </p:sp>
-      <p:sp>
-        <p:nvSpPr>
-          <p:cNvPr id="16" name="cardB"/>
-          <p:cNvSpPr/>
-          <p:nvPr/>
-        </p:nvSpPr>
-        <p:spPr>
-          <a:xfrm>
-            <a:off x="480000" y="1120000"/>
-            <a:ext cx="11000000" cy="5000000"/>
-          </a:xfrm>
-          <a:prstGeom prst="roundRect">
-            <a:avLst>
-              <a:gd name="adj" fmla="val 8000"/>
-            </a:avLst>
-          </a:prstGeom>
-          <a:noFill/>
-          <a:ln w="12700">
-            <a:solidFill>
-              <a:srgbClr val="BBF7D0"/>
-            </a:solidFill>
-          </a:ln>
-        </p:spPr>
-        <p:txBody>
-          <a:bodyPr/>
-          <a:lstStyle/>
-        </p:txBody>
-      </p:sp>
-      <p:sp>
-        <p:nvSpPr>
-          <p:cNvPr id="2" name="Title"/>
-          <p:cNvSpPr/>
-          <p:nvPr/>
-        </p:nvSpPr>
-        <p:spPr>
-          <a:xfrm>
-            <a:off x="600000" y="1040000"/>
-            <a:ext cx="10500000" cy="380000"/>
-          </a:xfrm>
-          <a:prstGeom prst="rect">
-            <a:avLst/>
-          </a:prstGeom>
-          <a:noFill/>
-          <a:ln>
-            <a:noFill/>
-          </a:ln>
-        </p:spPr>
-        <p:txBody>
-          <a:bodyPr anchor="t" wrap="square" lIns="91440" tIns="45720" rIns="91440" bIns="45720"/>
-          <a:lstStyle/>
-          <a:p>
-            <a:pPr algn="l"/>
-            <a:r>
-              <a:rPr sz="2400" b="1">
-                <a:solidFill>
-                  <a:srgbClr val="01773A"/>
-                </a:solidFill>
-                <a:latin typeface="Calibri Light"/>
-              </a:rPr>
-              <a:t>Выводы</a:t>
-            </a:r>
-          </a:p>
-        </p:txBody>
-      </p:sp>
-      <p:sp>
-        <p:nvSpPr>
-          <p:cNvPr id="3" name="Body"/>
-          <p:cNvSpPr/>
-          <p:nvPr/>
-        </p:nvSpPr>
-        <p:spPr>
-          <a:xfrm>
-            <a:off x="680000" y="1200000"/>
-            <a:ext cx="10400000" cy="4900000"/>
-          </a:xfrm>
-          <a:prstGeom prst="rect">
-            <a:avLst/>
-          </a:prstGeom>
-          <a:noFill/>
-          <a:ln>
-            <a:noFill/>
-          </a:ln>
-        </p:spPr>
-        <p:txBody>
-          <a:bodyPr anchor="t" wrap="square" lIns="91440" tIns="45720" rIns="91440" bIns="45720"/>
-          <a:lstStyle/>
-          <a:p>
-            <a:pPr marL="280000" indent="-140000" spcAft="700">
-              <a:buChar char="●"/>
-            </a:pPr>
-            <a:r>
-              <a:rPr sz="1620">
-                <a:solidFill>
-                  <a:srgbClr val="1E293B"/>
-                </a:solidFill>
-                <a:latin typeface="Calibri"/>
-              </a:rPr>
-              <a:t>Цель дипломного проекта достигнута</a:t>
-            </a:r>
-          </a:p>
-          <a:p>
-            <a:pPr marL="280000" indent="-140000" spcAft="700">
-              <a:buChar char="●"/>
-            </a:pPr>
-            <a:r>
-              <a:rPr sz="1620">
-                <a:solidFill>
-                  <a:srgbClr val="1E293B"/>
-                </a:solidFill>
-                <a:latin typeface="Calibri"/>
-              </a:rPr>
-              <a:t>Все задачи выполнены в полном объёме</a:t>
-            </a:r>
-          </a:p>
-          <a:p>
-            <a:pPr marL="280000" indent="-140000" spcAft="700">
-              <a:buChar char="●"/>
-            </a:pPr>
-            <a:r>
-              <a:rPr sz="1620">
-                <a:solidFill>
-                  <a:srgbClr val="1E293B"/>
-                </a:solidFill>
-                <a:latin typeface="Calibri"/>
-              </a:rPr>
-              <a:t>Модуль снижает нагрузку на менеджеров</a:t>
-            </a:r>
-          </a:p>
-          <a:p>
-            <a:pPr marL="280000" indent="-140000" spcAft="700">
-              <a:buChar char="●"/>
-            </a:pPr>
-            <a:r>
-              <a:rPr sz="1620">
-                <a:solidFill>
-                  <a:srgbClr val="1E293B"/>
-                </a:solidFill>
-                <a:latin typeface="Calibri"/>
-              </a:rPr>
-              <a:t>Экономическая эффективность подтверждена</a:t>
-            </a:r>
-          </a:p>
-        </p:txBody>
-      </p:sp>
-    </p:spTree>
-  </p:cSld>
-  <p:clrMapOvr>
-    <a:masterClrMapping/>
-  </p:clrMapOvr>
-</p:sld>
-</file>
-
-<file path=ppt/slides/slide15.xml><?xml version="1.0" encoding="utf-8"?>
-<p:sld xmlns:a="http://schemas.openxmlformats.org/drawingml/2006/main" xmlns:r="http://schemas.openxmlformats.org/officeDocument/2006/relationships" xmlns:p="http://schemas.openxmlformats.org/presentationml/2006/main">
-  <p:cSld name="Slide 15">
     <p:bg>
       <p:bgPr>
         <a:gradFill rotWithShape="1">
@@ -4214,7 +2410,7 @@
                 </a:solidFill>
                 <a:latin typeface="Calibri"/>
               </a:rPr>
-              <a:t>Турфирма «Бон Вояж»: +7 (4162) 317-771</a:t>
+              <a:t>ООО «Бон Вояж»: +7 (4162) 317-771</a:t>
             </a:r>
           </a:p>
         </p:txBody>
@@ -4493,21 +2689,21 @@
                 </a:solidFill>
                 <a:latin typeface="Calibri"/>
               </a:rPr>
-              <a:t>2 / 15</a:t>
-            </a:r>
-          </a:p>
-        </p:txBody>
-      </p:sp>
-      <p:sp>
-        <p:nvSpPr>
-          <p:cNvPr id="15" name="leftC"/>
+              <a:t>2 / 12</a:t>
+            </a:r>
+          </a:p>
+        </p:txBody>
+      </p:sp>
+      <p:sp>
+        <p:nvSpPr>
+          <p:cNvPr id="15" name="card"/>
           <p:cNvSpPr/>
           <p:nvPr/>
         </p:nvSpPr>
         <p:spPr>
           <a:xfrm>
             <a:off x="480000" y="1120000"/>
-            <a:ext cx="4800000" cy="5000000"/>
+            <a:ext cx="11000000" cy="5000000"/>
           </a:xfrm>
           <a:prstGeom prst="roundRect">
             <a:avLst>
@@ -4528,48 +2724,20 @@
       </p:sp>
       <p:sp>
         <p:nvSpPr>
-          <p:cNvPr id="16" name="rightC"/>
-          <p:cNvSpPr/>
-          <p:nvPr/>
-        </p:nvSpPr>
-        <p:spPr>
-          <a:xfrm>
-            <a:off x="5400000" y="1120000"/>
-            <a:ext cx="6200000" cy="5000000"/>
+          <p:cNvPr id="16" name="cardB"/>
+          <p:cNvSpPr/>
+          <p:nvPr/>
+        </p:nvSpPr>
+        <p:spPr>
+          <a:xfrm>
+            <a:off x="480000" y="1120000"/>
+            <a:ext cx="11000000" cy="5000000"/>
           </a:xfrm>
           <a:prstGeom prst="roundRect">
             <a:avLst>
               <a:gd name="adj" fmla="val 8000"/>
             </a:avLst>
           </a:prstGeom>
-          <a:solidFill>
-            <a:srgbClr val="FFFFFF"/>
-          </a:solidFill>
-          <a:ln>
-            <a:noFill/>
-          </a:ln>
-        </p:spPr>
-        <p:txBody>
-          <a:bodyPr/>
-          <a:lstStyle/>
-        </p:txBody>
-      </p:sp>
-      <p:sp>
-        <p:nvSpPr>
-          <p:cNvPr id="21" name="rightB"/>
-          <p:cNvSpPr/>
-          <p:nvPr/>
-        </p:nvSpPr>
-        <p:spPr>
-          <a:xfrm>
-            <a:off x="5400000" y="1120000"/>
-            <a:ext cx="6200000" cy="5000000"/>
-          </a:xfrm>
-          <a:prstGeom prst="roundRect">
-            <a:avLst>
-              <a:gd name="adj" fmla="val 8000"/>
-            </a:avLst>
-          </a:prstGeom>
           <a:noFill/>
           <a:ln w="12700">
             <a:solidFill>
@@ -4590,7 +2758,7 @@
         </p:nvSpPr>
         <p:spPr>
           <a:xfrm>
-            <a:off x="560000" y="1040000"/>
+            <a:off x="600000" y="1040000"/>
             <a:ext cx="10500000" cy="380000"/>
           </a:xfrm>
           <a:prstGeom prst="rect">
@@ -4626,8 +2794,8 @@
         </p:nvSpPr>
         <p:spPr>
           <a:xfrm>
-            <a:off x="600000" y="1200000"/>
-            <a:ext cx="4600000" cy="4800000"/>
+            <a:off x="680000" y="1200000"/>
+            <a:ext cx="10400000" cy="4900000"/>
           </a:xfrm>
           <a:prstGeom prst="rect">
             <a:avLst/>
@@ -4651,7 +2819,7 @@
                 </a:solidFill>
                 <a:latin typeface="Calibri"/>
               </a:rPr>
-              <a:t>Клиенты турфирм ожидают быстрый онлайн-подбор</a:t>
+              <a:t>Рост спроса на персонализированные туры</a:t>
             </a:r>
           </a:p>
           <a:p>
@@ -4665,7 +2833,7 @@
                 </a:solidFill>
                 <a:latin typeface="Calibri"/>
               </a:rPr>
-              <a:t>Свободный текст удобнее форм и фильтров</a:t>
+              <a:t>Клиенты тратят часы на поиск на сайтах операторов</a:t>
             </a:r>
           </a:p>
           <a:p>
@@ -4679,7 +2847,7 @@
                 </a:solidFill>
                 <a:latin typeface="Calibri"/>
               </a:rPr>
-              <a:t>LLM понимают запрос на русском языке</a:t>
+              <a:t>Менеджеры обрабатывают однотипные запросы вручную</a:t>
             </a:r>
           </a:p>
           <a:p>
@@ -4693,121 +2861,21 @@
                 </a:solidFill>
                 <a:latin typeface="Calibri"/>
               </a:rPr>
-              <a:t>Автоматизация работает 24/7 без выходных</a:t>
-            </a:r>
-          </a:p>
-        </p:txBody>
-      </p:sp>
-      <p:sp>
-        <p:nvSpPr>
-          <p:cNvPr id="4" name="Detail"/>
-          <p:cNvSpPr/>
-          <p:nvPr/>
-        </p:nvSpPr>
-        <p:spPr>
-          <a:xfrm>
-            <a:off x="5520000" y="1180000"/>
-            <a:ext cx="6000000" cy="4900000"/>
-          </a:xfrm>
-          <a:prstGeom prst="rect">
-            <a:avLst/>
-          </a:prstGeom>
-          <a:noFill/>
-          <a:ln>
-            <a:noFill/>
-          </a:ln>
-        </p:spPr>
-        <p:txBody>
-          <a:bodyPr anchor="t" wrap="square" lIns="91440" tIns="45720" rIns="91440" bIns="45720"/>
-          <a:lstStyle/>
-          <a:p>
-            <a:pPr algn="l" spcAft="400"/>
-            <a:r>
-              <a:rPr sz="1500" b="1">
-                <a:solidFill>
-                  <a:srgbClr val="01773A"/>
-                </a:solidFill>
-                <a:latin typeface="Calibri"/>
-              </a:rPr>
-              <a:t>ПРОБЛЕМА</a:t>
-            </a:r>
-          </a:p>
-          <a:p>
-            <a:pPr algn="l" spcAft="120"/>
-            <a:r>
-              <a:rPr sz="1450">
-                <a:solidFill>
-                  <a:srgbClr val="1E293B"/>
-                </a:solidFill>
-                <a:latin typeface="Calibri"/>
-              </a:rPr>
-              <a:t>Менеджер не всегда может ответить сразу — клиент уходит к конкурентам.</a:t>
-            </a:r>
-          </a:p>
-          <a:p>
-            <a:pPr spcAft="200"/>
-          </a:p>
-          <a:p>
-            <a:pPr algn="l" spcAft="400"/>
-            <a:r>
-              <a:rPr sz="1500" b="1">
-                <a:solidFill>
-                  <a:srgbClr val="01773A"/>
-                </a:solidFill>
-                <a:latin typeface="Calibri"/>
-              </a:rPr>
-              <a:t>РЕШЕНИЕ</a:t>
-            </a:r>
-          </a:p>
-          <a:p>
-            <a:pPr algn="l" spcAft="120"/>
-            <a:r>
-              <a:rPr sz="1450">
-                <a:solidFill>
-                  <a:srgbClr val="1E293B"/>
-                </a:solidFill>
-                <a:latin typeface="Calibri"/>
-              </a:rPr>
-              <a:t>Модуль принимает запрос в свободной форме:</a:t>
-            </a:r>
-          </a:p>
-          <a:p>
-            <a:pPr algn="l" spcAft="120"/>
-            <a:r>
-              <a:rPr sz="1450">
-                <a:solidFill>
-                  <a:srgbClr val="1E293B"/>
-                </a:solidFill>
-                <a:latin typeface="Calibri"/>
-              </a:rPr>
-              <a:t>«Хочу в Китай с 10 по 20 июля, бюджет 80 000 руб.»</a:t>
-            </a:r>
-          </a:p>
-          <a:p>
-            <a:pPr spcAft="200"/>
-          </a:p>
-          <a:p>
-            <a:pPr algn="l" spcAft="400"/>
-            <a:r>
-              <a:rPr sz="1500" b="1">
-                <a:solidFill>
-                  <a:srgbClr val="01773A"/>
-                </a:solidFill>
-                <a:latin typeface="Calibri"/>
-              </a:rPr>
-              <a:t>ВЫГОДА</a:t>
-            </a:r>
-          </a:p>
-          <a:p>
-            <a:pPr algn="l" spcAft="120"/>
-            <a:r>
-              <a:rPr sz="1450">
-                <a:solidFill>
-                  <a:srgbClr val="1E293B"/>
-                </a:solidFill>
-                <a:latin typeface="Calibri"/>
-              </a:rPr>
-              <a:t>Снижение нагрузки на сотрудников, рост числа заявок.</a:t>
+              <a:t>LLM автоматизируют извлечение параметров из текста</a:t>
+            </a:r>
+          </a:p>
+          <a:p>
+            <a:pPr marL="280000" indent="-140000" spcAft="700">
+              <a:buChar char="●"/>
+            </a:pPr>
+            <a:r>
+              <a:rPr sz="1620">
+                <a:solidFill>
+                  <a:srgbClr val="1E293B"/>
+                </a:solidFill>
+                <a:latin typeface="Calibri"/>
+              </a:rPr>
+              <a:t>Модуль работает на сайте 24/7 без выходных</a:t>
             </a:r>
           </a:p>
         </p:txBody>
@@ -5086,7 +3154,7 @@
                 </a:solidFill>
                 <a:latin typeface="Calibri"/>
               </a:rPr>
-              <a:t>3 / 15</a:t>
+              <a:t>3 / 12</a:t>
             </a:r>
           </a:p>
         </p:txBody>
@@ -5178,7 +3246,7 @@
                 </a:solidFill>
                 <a:latin typeface="Calibri Light"/>
               </a:rPr>
-              <a:t>Цель и задачи проекта</a:t>
+              <a:t>Цель и задачи</a:t>
             </a:r>
           </a:p>
         </p:txBody>
@@ -5216,7 +3284,7 @@
                 </a:solidFill>
                 <a:latin typeface="Calibri"/>
               </a:rPr>
-              <a:t>Цель: разработать модуль генерации турпакета на основе ИИ</a:t>
+              <a:t>Цель: разработать и внедрить систему генерации турпакета на основе ИИ</a:t>
             </a:r>
           </a:p>
           <a:p>
@@ -5230,7 +3298,7 @@
                 </a:solidFill>
                 <a:latin typeface="Calibri"/>
               </a:rPr>
-              <a:t>Изучить применение LLM в туризме</a:t>
+              <a:t>Анализ деятельности туроператора и процесса подбора туров</a:t>
             </a:r>
           </a:p>
           <a:p>
@@ -5244,7 +3312,7 @@
                 </a:solidFill>
                 <a:latin typeface="Calibri"/>
               </a:rPr>
-              <a:t>Спроектировать архитектуру, БД и AI-агента</a:t>
+              <a:t>Сравнительный анализ аналогов и выбор технологий</a:t>
             </a:r>
           </a:p>
           <a:p>
@@ -5258,7 +3326,7 @@
                 </a:solidFill>
                 <a:latin typeface="Calibri"/>
               </a:rPr>
-              <a:t>Реализовать интерфейс, сервер и парсер</a:t>
+              <a:t>Проектирование архитектуры модуля и структуры БД</a:t>
             </a:r>
           </a:p>
           <a:p>
@@ -5272,7 +3340,7 @@
                 </a:solidFill>
                 <a:latin typeface="Calibri"/>
               </a:rPr>
-              <a:t>Интегрировать DeepSeek и GigaChat</a:t>
+              <a:t>Реализация парсера, бэкенда FastAPI и фронтенда Vue.js</a:t>
             </a:r>
           </a:p>
           <a:p>
@@ -5286,7 +3354,7 @@
                 </a:solidFill>
                 <a:latin typeface="Calibri"/>
               </a:rPr>
-              <a:t>Провести тестирование и экономическое обоснование</a:t>
+              <a:t>Интеграция LLM, тестирование и экономическое обоснование</a:t>
             </a:r>
           </a:p>
         </p:txBody>
@@ -5565,21 +3633,21 @@
                 </a:solidFill>
                 <a:latin typeface="Calibri"/>
               </a:rPr>
-              <a:t>4 / 15</a:t>
-            </a:r>
-          </a:p>
-        </p:txBody>
-      </p:sp>
-      <p:sp>
-        <p:nvSpPr>
-          <p:cNvPr id="15" name="card"/>
+              <a:t>4 / 12</a:t>
+            </a:r>
+          </a:p>
+        </p:txBody>
+      </p:sp>
+      <p:sp>
+        <p:nvSpPr>
+          <p:cNvPr id="15" name="leftC"/>
           <p:cNvSpPr/>
           <p:nvPr/>
         </p:nvSpPr>
         <p:spPr>
           <a:xfrm>
             <a:off x="480000" y="1120000"/>
-            <a:ext cx="11000000" cy="5000000"/>
+            <a:ext cx="4800000" cy="5000000"/>
           </a:xfrm>
           <a:prstGeom prst="roundRect">
             <a:avLst>
@@ -5600,20 +3668,48 @@
       </p:sp>
       <p:sp>
         <p:nvSpPr>
-          <p:cNvPr id="16" name="cardB"/>
-          <p:cNvSpPr/>
-          <p:nvPr/>
-        </p:nvSpPr>
-        <p:spPr>
-          <a:xfrm>
-            <a:off x="480000" y="1120000"/>
-            <a:ext cx="11000000" cy="5000000"/>
+          <p:cNvPr id="16" name="rightC"/>
+          <p:cNvSpPr/>
+          <p:nvPr/>
+        </p:nvSpPr>
+        <p:spPr>
+          <a:xfrm>
+            <a:off x="5400000" y="1120000"/>
+            <a:ext cx="6200000" cy="5000000"/>
           </a:xfrm>
           <a:prstGeom prst="roundRect">
             <a:avLst>
               <a:gd name="adj" fmla="val 8000"/>
             </a:avLst>
           </a:prstGeom>
+          <a:solidFill>
+            <a:srgbClr val="FFFFFF"/>
+          </a:solidFill>
+          <a:ln>
+            <a:noFill/>
+          </a:ln>
+        </p:spPr>
+        <p:txBody>
+          <a:bodyPr/>
+          <a:lstStyle/>
+        </p:txBody>
+      </p:sp>
+      <p:sp>
+        <p:nvSpPr>
+          <p:cNvPr id="21" name="rightB"/>
+          <p:cNvSpPr/>
+          <p:nvPr/>
+        </p:nvSpPr>
+        <p:spPr>
+          <a:xfrm>
+            <a:off x="5400000" y="1120000"/>
+            <a:ext cx="6200000" cy="5000000"/>
+          </a:xfrm>
+          <a:prstGeom prst="roundRect">
+            <a:avLst>
+              <a:gd name="adj" fmla="val 8000"/>
+            </a:avLst>
+          </a:prstGeom>
           <a:noFill/>
           <a:ln w="12700">
             <a:solidFill>
@@ -5634,7 +3730,7 @@
         </p:nvSpPr>
         <p:spPr>
           <a:xfrm>
-            <a:off x="600000" y="1040000"/>
+            <a:off x="560000" y="1040000"/>
             <a:ext cx="10500000" cy="380000"/>
           </a:xfrm>
           <a:prstGeom prst="rect">
@@ -5657,7 +3753,7 @@
                 </a:solidFill>
                 <a:latin typeface="Calibri Light"/>
               </a:rPr>
-              <a:t>Объект и предмет исследования</a:t>
+              <a:t>Сравнение аналогов</a:t>
             </a:r>
           </a:p>
         </p:txBody>
@@ -5670,8 +3766,8 @@
         </p:nvSpPr>
         <p:spPr>
           <a:xfrm>
-            <a:off x="680000" y="1200000"/>
-            <a:ext cx="10400000" cy="4900000"/>
+            <a:off x="600000" y="1200000"/>
+            <a:ext cx="4600000" cy="4800000"/>
           </a:xfrm>
           <a:prstGeom prst="rect">
             <a:avLst/>
@@ -5695,7 +3791,7 @@
                 </a:solidFill>
                 <a:latin typeface="Calibri"/>
               </a:rPr>
-              <a:t>Объект: процесс подбора турпакета в турфирме</a:t>
+              <a:t>Travelpayouts, Tutu.ru, Яндекс.Путешествия — только формы</a:t>
             </a:r>
           </a:p>
           <a:p>
@@ -5709,7 +3805,7 @@
                 </a:solidFill>
                 <a:latin typeface="Calibri"/>
               </a:rPr>
-              <a:t>Предмет: методы применения ИИ для генерации турпакета</a:t>
+              <a:t>CRM (1С: Турагентство) — учёт, но без ИИ и диалога</a:t>
             </a:r>
           </a:p>
           <a:p>
@@ -5723,7 +3819,7 @@
                 </a:solidFill>
                 <a:latin typeface="Calibri"/>
               </a:rPr>
-              <a:t>База практики: ООО «Бон Вояж», bon-voyage28.ru</a:t>
+              <a:t>Готовые чат-боты — чужой каталог, нет привязки к «Бон Вояж»</a:t>
             </a:r>
           </a:p>
           <a:p>
@@ -5737,7 +3833,157 @@
                 </a:solidFill>
                 <a:latin typeface="Calibri"/>
               </a:rPr>
-              <a:t>Результат: модуль для сайта «Планета 360»</a:t>
+              <a:t>Ни один аналог не сочетает все три функции сразу</a:t>
+            </a:r>
+          </a:p>
+        </p:txBody>
+      </p:sp>
+      <p:sp>
+        <p:nvSpPr>
+          <p:cNvPr id="4" name="Detail"/>
+          <p:cNvSpPr/>
+          <p:nvPr/>
+        </p:nvSpPr>
+        <p:spPr>
+          <a:xfrm>
+            <a:off x="5520000" y="1180000"/>
+            <a:ext cx="6000000" cy="4900000"/>
+          </a:xfrm>
+          <a:prstGeom prst="rect">
+            <a:avLst/>
+          </a:prstGeom>
+          <a:noFill/>
+          <a:ln>
+            <a:noFill/>
+          </a:ln>
+        </p:spPr>
+        <p:txBody>
+          <a:bodyPr anchor="t" wrap="square" lIns="91440" tIns="45720" rIns="91440" bIns="45720"/>
+          <a:lstStyle/>
+          <a:p>
+            <a:pPr algn="l" spcAft="400"/>
+            <a:r>
+              <a:rPr sz="1500" b="1">
+                <a:solidFill>
+                  <a:srgbClr val="01773A"/>
+                </a:solidFill>
+                <a:latin typeface="Calibri"/>
+              </a:rPr>
+              <a:t>КРИТЕРИИ СРАВНЕНИЯ</a:t>
+            </a:r>
+          </a:p>
+          <a:p>
+            <a:pPr algn="l" spcAft="100"/>
+            <a:r>
+              <a:rPr sz="1450">
+                <a:solidFill>
+                  <a:srgbClr val="1E293B"/>
+                </a:solidFill>
+                <a:latin typeface="Calibri"/>
+              </a:rPr>
+              <a:t>· Ввод запроса (форма / свободный текст)</a:t>
+            </a:r>
+          </a:p>
+          <a:p>
+            <a:pPr algn="l" spcAft="100"/>
+            <a:r>
+              <a:rPr sz="1450">
+                <a:solidFill>
+                  <a:srgbClr val="1E293B"/>
+                </a:solidFill>
+                <a:latin typeface="Calibri"/>
+              </a:rPr>
+              <a:t>· Диалог для уточнения параметров</a:t>
+            </a:r>
+          </a:p>
+          <a:p>
+            <a:pPr algn="l" spcAft="100"/>
+            <a:r>
+              <a:rPr sz="1450">
+                <a:solidFill>
+                  <a:srgbClr val="1E293B"/>
+                </a:solidFill>
+                <a:latin typeface="Calibri"/>
+              </a:rPr>
+              <a:t>· Работа с каталогом конкретной турфирмы</a:t>
+            </a:r>
+          </a:p>
+          <a:p>
+            <a:pPr spcAft="200"/>
+          </a:p>
+          <a:p>
+            <a:pPr algn="l" spcAft="400"/>
+            <a:r>
+              <a:rPr sz="1500" b="1">
+                <a:solidFill>
+                  <a:srgbClr val="01773A"/>
+                </a:solidFill>
+                <a:latin typeface="Calibri"/>
+              </a:rPr>
+              <a:t>ПОИСКОВИКИ</a:t>
+            </a:r>
+          </a:p>
+          <a:p>
+            <a:pPr algn="l" spcAft="100"/>
+            <a:r>
+              <a:rPr sz="1450">
+                <a:solidFill>
+                  <a:srgbClr val="1E293B"/>
+                </a:solidFill>
+                <a:latin typeface="Calibri"/>
+              </a:rPr>
+              <a:t>· Большая база, актуальные цены</a:t>
+            </a:r>
+          </a:p>
+          <a:p>
+            <a:pPr algn="l" spcAft="100"/>
+            <a:r>
+              <a:rPr sz="1450">
+                <a:solidFill>
+                  <a:srgbClr val="1E293B"/>
+                </a:solidFill>
+                <a:latin typeface="Calibri"/>
+              </a:rPr>
+              <a:t>· Нет NLP и диалога</a:t>
+            </a:r>
+          </a:p>
+          <a:p>
+            <a:pPr spcAft="200"/>
+          </a:p>
+          <a:p>
+            <a:pPr algn="l" spcAft="400"/>
+            <a:r>
+              <a:rPr sz="1500" b="1">
+                <a:solidFill>
+                  <a:srgbClr val="01773A"/>
+                </a:solidFill>
+                <a:latin typeface="Calibri"/>
+              </a:rPr>
+              <a:t>НАШ МОДУЛЬ</a:t>
+            </a:r>
+          </a:p>
+          <a:p>
+            <a:pPr algn="l" spcAft="100"/>
+            <a:r>
+              <a:rPr sz="1450">
+                <a:solidFill>
+                  <a:srgbClr val="1E293B"/>
+                </a:solidFill>
+                <a:latin typeface="Calibri"/>
+              </a:rPr>
+              <a:t>· NLP + диалог + свой каталог</a:t>
+            </a:r>
+          </a:p>
+          <a:p>
+            <a:pPr algn="l" spcAft="100"/>
+            <a:r>
+              <a:rPr sz="1450">
+                <a:solidFill>
+                  <a:srgbClr val="1E293B"/>
+                </a:solidFill>
+                <a:latin typeface="Calibri"/>
+              </a:rPr>
+              <a:t>· Интеграция в bon-voyage28.ru</a:t>
             </a:r>
           </a:p>
         </p:txBody>
@@ -6016,21 +4262,21 @@
                 </a:solidFill>
                 <a:latin typeface="Calibri"/>
               </a:rPr>
-              <a:t>5 / 15</a:t>
-            </a:r>
-          </a:p>
-        </p:txBody>
-      </p:sp>
-      <p:sp>
-        <p:nvSpPr>
-          <p:cNvPr id="15" name="leftC"/>
+              <a:t>5 / 12</a:t>
+            </a:r>
+          </a:p>
+        </p:txBody>
+      </p:sp>
+      <p:sp>
+        <p:nvSpPr>
+          <p:cNvPr id="15" name="card"/>
           <p:cNvSpPr/>
           <p:nvPr/>
         </p:nvSpPr>
         <p:spPr>
           <a:xfrm>
             <a:off x="480000" y="1120000"/>
-            <a:ext cx="4800000" cy="5000000"/>
+            <a:ext cx="11000000" cy="5000000"/>
           </a:xfrm>
           <a:prstGeom prst="roundRect">
             <a:avLst>
@@ -6051,48 +4297,20 @@
       </p:sp>
       <p:sp>
         <p:nvSpPr>
-          <p:cNvPr id="16" name="rightC"/>
-          <p:cNvSpPr/>
-          <p:nvPr/>
-        </p:nvSpPr>
-        <p:spPr>
-          <a:xfrm>
-            <a:off x="5400000" y="1120000"/>
-            <a:ext cx="6200000" cy="5000000"/>
+          <p:cNvPr id="16" name="cardB"/>
+          <p:cNvSpPr/>
+          <p:nvPr/>
+        </p:nvSpPr>
+        <p:spPr>
+          <a:xfrm>
+            <a:off x="480000" y="1120000"/>
+            <a:ext cx="11000000" cy="5000000"/>
           </a:xfrm>
           <a:prstGeom prst="roundRect">
             <a:avLst>
               <a:gd name="adj" fmla="val 8000"/>
             </a:avLst>
           </a:prstGeom>
-          <a:solidFill>
-            <a:srgbClr val="FFFFFF"/>
-          </a:solidFill>
-          <a:ln>
-            <a:noFill/>
-          </a:ln>
-        </p:spPr>
-        <p:txBody>
-          <a:bodyPr/>
-          <a:lstStyle/>
-        </p:txBody>
-      </p:sp>
-      <p:sp>
-        <p:nvSpPr>
-          <p:cNvPr id="21" name="rightB"/>
-          <p:cNvSpPr/>
-          <p:nvPr/>
-        </p:nvSpPr>
-        <p:spPr>
-          <a:xfrm>
-            <a:off x="5400000" y="1120000"/>
-            <a:ext cx="6200000" cy="5000000"/>
-          </a:xfrm>
-          <a:prstGeom prst="roundRect">
-            <a:avLst>
-              <a:gd name="adj" fmla="val 8000"/>
-            </a:avLst>
-          </a:prstGeom>
           <a:noFill/>
           <a:ln w="12700">
             <a:solidFill>
@@ -6113,7 +4331,7 @@
         </p:nvSpPr>
         <p:spPr>
           <a:xfrm>
-            <a:off x="560000" y="1040000"/>
+            <a:off x="600000" y="1040000"/>
             <a:ext cx="10500000" cy="380000"/>
           </a:xfrm>
           <a:prstGeom prst="rect">
@@ -6136,7 +4354,7 @@
                 </a:solidFill>
                 <a:latin typeface="Calibri Light"/>
               </a:rPr>
-              <a:t>Средства разработки</a:t>
+              <a:t>Объект и предмет исследования</a:t>
             </a:r>
           </a:p>
         </p:txBody>
@@ -6149,8 +4367,8 @@
         </p:nvSpPr>
         <p:spPr>
           <a:xfrm>
-            <a:off x="600000" y="1200000"/>
-            <a:ext cx="4600000" cy="4800000"/>
+            <a:off x="680000" y="1200000"/>
+            <a:ext cx="10400000" cy="4900000"/>
           </a:xfrm>
           <a:prstGeom prst="rect">
             <a:avLst/>
@@ -6174,7 +4392,7 @@
                 </a:solidFill>
                 <a:latin typeface="Calibri"/>
               </a:rPr>
-              <a:t>Python 3.11 — основной язык</a:t>
+              <a:t>Объект: процесс подбора туристических пакетов в деятельности туроператора</a:t>
             </a:r>
           </a:p>
           <a:p>
@@ -6188,7 +4406,7 @@
                 </a:solidFill>
                 <a:latin typeface="Calibri"/>
               </a:rPr>
-              <a:t>FastAPI + Uvicorn — сервер</a:t>
+              <a:t>Предмет: методы сбора данных и обработки с LLM для генерации турпакетов</a:t>
             </a:r>
           </a:p>
           <a:p>
@@ -6202,7 +4420,7 @@
                 </a:solidFill>
                 <a:latin typeface="Calibri"/>
               </a:rPr>
-              <a:t>Vue.js — клиентский интерфейс</a:t>
+              <a:t>Практическая база: ООО «Бон Вояж», г. Благовещенск</a:t>
             </a:r>
           </a:p>
           <a:p>
@@ -6216,143 +4434,7 @@
                 </a:solidFill>
                 <a:latin typeface="Calibri"/>
               </a:rPr>
-              <a:t>MySQL 8.0 — база данных</a:t>
-            </a:r>
-          </a:p>
-          <a:p>
-            <a:pPr marL="280000" indent="-140000" spcAft="700">
-              <a:buChar char="●"/>
-            </a:pPr>
-            <a:r>
-              <a:rPr sz="1620">
-                <a:solidFill>
-                  <a:srgbClr val="1E293B"/>
-                </a:solidFill>
-                <a:latin typeface="Calibri"/>
-              </a:rPr>
-              <a:t>DeepSeek API, GigaChat — LLM</a:t>
-            </a:r>
-          </a:p>
-          <a:p>
-            <a:pPr marL="280000" indent="-140000" spcAft="700">
-              <a:buChar char="●"/>
-            </a:pPr>
-            <a:r>
-              <a:rPr sz="1620">
-                <a:solidFill>
-                  <a:srgbClr val="1E293B"/>
-                </a:solidFill>
-                <a:latin typeface="Calibri"/>
-              </a:rPr>
-              <a:t>BeautifulSoup — парсер каталога</a:t>
-            </a:r>
-          </a:p>
-        </p:txBody>
-      </p:sp>
-      <p:sp>
-        <p:nvSpPr>
-          <p:cNvPr id="4" name="Detail"/>
-          <p:cNvSpPr/>
-          <p:nvPr/>
-        </p:nvSpPr>
-        <p:spPr>
-          <a:xfrm>
-            <a:off x="5520000" y="1180000"/>
-            <a:ext cx="6000000" cy="4900000"/>
-          </a:xfrm>
-          <a:prstGeom prst="rect">
-            <a:avLst/>
-          </a:prstGeom>
-          <a:noFill/>
-          <a:ln>
-            <a:noFill/>
-          </a:ln>
-        </p:spPr>
-        <p:txBody>
-          <a:bodyPr anchor="t" wrap="square" lIns="91440" tIns="45720" rIns="91440" bIns="45720"/>
-          <a:lstStyle/>
-          <a:p>
-            <a:pPr algn="l" spcAft="400"/>
-            <a:r>
-              <a:rPr sz="1500" b="1">
-                <a:solidFill>
-                  <a:srgbClr val="01773A"/>
-                </a:solidFill>
-                <a:latin typeface="Calibri"/>
-              </a:rPr>
-              <a:t>СТЕК ТЕХНОЛОГИЙ</a:t>
-            </a:r>
-          </a:p>
-          <a:p>
-            <a:pPr algn="l" spcAft="120"/>
-            <a:r>
-              <a:rPr sz="1450">
-                <a:solidFill>
-                  <a:srgbClr val="1E293B"/>
-                </a:solidFill>
-                <a:latin typeface="Calibri"/>
-              </a:rPr>
-              <a:t>Backend:  app.py, ai_service.py, config.py</a:t>
-            </a:r>
-          </a:p>
-          <a:p>
-            <a:pPr algn="l" spcAft="120"/>
-            <a:r>
-              <a:rPr sz="1450">
-                <a:solidFill>
-                  <a:srgbClr val="1E293B"/>
-                </a:solidFill>
-                <a:latin typeface="Calibri"/>
-              </a:rPr>
-              <a:t>Frontend: frontend/index.html (Vue SPA)</a:t>
-            </a:r>
-          </a:p>
-          <a:p>
-            <a:pPr algn="l" spcAft="120"/>
-            <a:r>
-              <a:rPr sz="1450">
-                <a:solidFill>
-                  <a:srgbClr val="1E293B"/>
-                </a:solidFill>
-                <a:latin typeface="Calibri"/>
-              </a:rPr>
-              <a:t>Парсер:   parser.py → таблица hotels</a:t>
-            </a:r>
-          </a:p>
-          <a:p>
-            <a:pPr algn="l" spcAft="120"/>
-            <a:r>
-              <a:rPr sz="1450">
-                <a:solidFill>
-                  <a:srgbClr val="1E293B"/>
-                </a:solidFill>
-                <a:latin typeface="Calibri"/>
-              </a:rPr>
-              <a:t>Конфиг:   .env + requirements.txt</a:t>
-            </a:r>
-          </a:p>
-          <a:p>
-            <a:pPr algn="l" spcAft="120"/>
-            <a:r>
-              <a:rPr sz="1450">
-                <a:solidFill>
-                  <a:srgbClr val="1E293B"/>
-                </a:solidFill>
-                <a:latin typeface="Calibri"/>
-              </a:rPr>
-              <a:t>Запуск:   python run_server.py</a:t>
-            </a:r>
-          </a:p>
-          <a:p>
-            <a:pPr algn="l" spcAft="120"/>
-            <a:r>
-              <a:rPr sz="1450">
-                <a:solidFill>
-                  <a:srgbClr val="1E293B"/>
-                </a:solidFill>
-                <a:latin typeface="Calibri"/>
-              </a:rPr>
-              <a:t>Адрес:    http://localhost:8000</a:t>
+              <a:t>Результат: модуль «AI Тур-Генератор» для сайта Планета 360</a:t>
             </a:r>
           </a:p>
         </p:txBody>
@@ -6631,21 +4713,21 @@
                 </a:solidFill>
                 <a:latin typeface="Calibri"/>
               </a:rPr>
-              <a:t>6 / 15</a:t>
-            </a:r>
-          </a:p>
-        </p:txBody>
-      </p:sp>
-      <p:sp>
-        <p:nvSpPr>
-          <p:cNvPr id="15" name="leftC"/>
+              <a:t>6 / 12</a:t>
+            </a:r>
+          </a:p>
+        </p:txBody>
+      </p:sp>
+      <p:sp>
+        <p:nvSpPr>
+          <p:cNvPr id="15" name="card"/>
           <p:cNvSpPr/>
           <p:nvPr/>
         </p:nvSpPr>
         <p:spPr>
           <a:xfrm>
             <a:off x="480000" y="1120000"/>
-            <a:ext cx="4800000" cy="5000000"/>
+            <a:ext cx="11000000" cy="5000000"/>
           </a:xfrm>
           <a:prstGeom prst="roundRect">
             <a:avLst>
@@ -6666,48 +4748,20 @@
       </p:sp>
       <p:sp>
         <p:nvSpPr>
-          <p:cNvPr id="16" name="rightC"/>
-          <p:cNvSpPr/>
-          <p:nvPr/>
-        </p:nvSpPr>
-        <p:spPr>
-          <a:xfrm>
-            <a:off x="5400000" y="1120000"/>
-            <a:ext cx="6200000" cy="5000000"/>
+          <p:cNvPr id="16" name="cardB"/>
+          <p:cNvSpPr/>
+          <p:nvPr/>
+        </p:nvSpPr>
+        <p:spPr>
+          <a:xfrm>
+            <a:off x="480000" y="1120000"/>
+            <a:ext cx="11000000" cy="5000000"/>
           </a:xfrm>
           <a:prstGeom prst="roundRect">
             <a:avLst>
               <a:gd name="adj" fmla="val 8000"/>
             </a:avLst>
           </a:prstGeom>
-          <a:solidFill>
-            <a:srgbClr val="FFFFFF"/>
-          </a:solidFill>
-          <a:ln>
-            <a:noFill/>
-          </a:ln>
-        </p:spPr>
-        <p:txBody>
-          <a:bodyPr/>
-          <a:lstStyle/>
-        </p:txBody>
-      </p:sp>
-      <p:sp>
-        <p:nvSpPr>
-          <p:cNvPr id="21" name="rightB"/>
-          <p:cNvSpPr/>
-          <p:nvPr/>
-        </p:nvSpPr>
-        <p:spPr>
-          <a:xfrm>
-            <a:off x="5400000" y="1120000"/>
-            <a:ext cx="6200000" cy="5000000"/>
-          </a:xfrm>
-          <a:prstGeom prst="roundRect">
-            <a:avLst>
-              <a:gd name="adj" fmla="val 8000"/>
-            </a:avLst>
-          </a:prstGeom>
           <a:noFill/>
           <a:ln w="12700">
             <a:solidFill>
@@ -6728,7 +4782,7 @@
         </p:nvSpPr>
         <p:spPr>
           <a:xfrm>
-            <a:off x="560000" y="1040000"/>
+            <a:off x="600000" y="1040000"/>
             <a:ext cx="10500000" cy="380000"/>
           </a:xfrm>
           <a:prstGeom prst="rect">
@@ -6751,7 +4805,7 @@
                 </a:solidFill>
                 <a:latin typeface="Calibri Light"/>
               </a:rPr>
-              <a:t>Архитектура системы</a:t>
+              <a:t>Средства разработки</a:t>
             </a:r>
           </a:p>
         </p:txBody>
@@ -6764,8 +4818,8 @@
         </p:nvSpPr>
         <p:spPr>
           <a:xfrm>
-            <a:off x="600000" y="1200000"/>
-            <a:ext cx="4600000" cy="4800000"/>
+            <a:off x="680000" y="1200000"/>
+            <a:ext cx="10400000" cy="4900000"/>
           </a:xfrm>
           <a:prstGeom prst="rect">
             <a:avLst/>
@@ -6789,7 +4843,7 @@
                 </a:solidFill>
                 <a:latin typeface="Calibri"/>
               </a:rPr>
-              <a:t>Клиент-серверная архитектура</a:t>
+              <a:t>Python 3.11, FastAPI, Uvicorn — серверная часть</a:t>
             </a:r>
           </a:p>
           <a:p>
@@ -6803,7 +4857,7 @@
                 </a:solidFill>
                 <a:latin typeface="Calibri"/>
               </a:rPr>
-              <a:t>Три уровня: клиент → сервер → данные</a:t>
+              <a:t>Vue.js 3 — клиентский интерфейс (чат)</a:t>
             </a:r>
           </a:p>
           <a:p>
@@ -6817,196 +4871,49 @@
                 </a:solidFill>
                 <a:latin typeface="Calibri"/>
               </a:rPr>
-              <a:t>Два провайдера ИИ с fallback</a:t>
-            </a:r>
-          </a:p>
-        </p:txBody>
-      </p:sp>
-      <p:sp>
-        <p:nvSpPr>
-          <p:cNvPr id="4" name="Detail"/>
-          <p:cNvSpPr/>
-          <p:nvPr/>
-        </p:nvSpPr>
-        <p:spPr>
-          <a:xfrm>
-            <a:off x="5520000" y="1180000"/>
-            <a:ext cx="6000000" cy="4900000"/>
-          </a:xfrm>
-          <a:prstGeom prst="rect">
-            <a:avLst/>
-          </a:prstGeom>
-          <a:noFill/>
-          <a:ln>
-            <a:noFill/>
-          </a:ln>
-        </p:spPr>
-        <p:txBody>
-          <a:bodyPr anchor="t" wrap="square" lIns="91440" tIns="45720" rIns="91440" bIns="45720"/>
-          <a:lstStyle/>
-          <a:p>
-            <a:pPr algn="l" spcAft="120"/>
-            <a:r>
-              <a:rPr sz="1450">
-                <a:solidFill>
-                  <a:srgbClr val="1E293B"/>
-                </a:solidFill>
-                <a:latin typeface="Calibri"/>
-              </a:rPr>
-              <a:t>КЛИЕНТ (Vue.js)</a:t>
-            </a:r>
-          </a:p>
-          <a:p>
-            <a:pPr algn="l" spcAft="100"/>
-            <a:r>
-              <a:rPr sz="1450">
-                <a:solidFill>
-                  <a:srgbClr val="1E293B"/>
-                </a:solidFill>
-                <a:latin typeface="Calibri"/>
-              </a:rPr>
-              <a:t>· Чат-интерфейс, выбор LLM</a:t>
-            </a:r>
-          </a:p>
-          <a:p>
-            <a:pPr algn="l" spcAft="100"/>
-            <a:r>
-              <a:rPr sz="1450">
-                <a:solidFill>
-                  <a:srgbClr val="1E293B"/>
-                </a:solidFill>
-                <a:latin typeface="Calibri"/>
-              </a:rPr>
-              <a:t>· Карточка готового турпакета</a:t>
-            </a:r>
-          </a:p>
-          <a:p>
-            <a:pPr algn="l" spcAft="100"/>
-            <a:r>
-              <a:rPr sz="1450">
-                <a:solidFill>
-                  <a:srgbClr val="1E293B"/>
-                </a:solidFill>
-                <a:latin typeface="Calibri"/>
-              </a:rPr>
-              <a:t>· Форма заявки менеджеру</a:t>
-            </a:r>
-          </a:p>
-          <a:p>
-            <a:pPr spcAft="200"/>
-          </a:p>
-          <a:p>
-            <a:pPr algn="l" spcAft="120"/>
-            <a:r>
-              <a:rPr sz="1450">
-                <a:solidFill>
-                  <a:srgbClr val="1E293B"/>
-                </a:solidFill>
-                <a:latin typeface="Calibri"/>
-              </a:rPr>
-              <a:t>СЕРВЕР (FastAPI)</a:t>
-            </a:r>
-          </a:p>
-          <a:p>
-            <a:pPr algn="l" spcAft="100"/>
-            <a:r>
-              <a:rPr sz="1450">
-                <a:solidFill>
-                  <a:srgbClr val="1E293B"/>
-                </a:solidFill>
-                <a:latin typeface="Calibri"/>
-              </a:rPr>
-              <a:t>· POST /api/chat — основной эндпоинт</a:t>
-            </a:r>
-          </a:p>
-          <a:p>
-            <a:pPr algn="l" spcAft="100"/>
-            <a:r>
-              <a:rPr sz="1450">
-                <a:solidFill>
-                  <a:srgbClr val="1E293B"/>
-                </a:solidFill>
-                <a:latin typeface="Calibri"/>
-              </a:rPr>
-              <a:t>· ai_service.py — логика AI-агента</a:t>
-            </a:r>
-          </a:p>
-          <a:p>
-            <a:pPr algn="l" spcAft="100"/>
-            <a:r>
-              <a:rPr sz="1450">
-                <a:solidFill>
-                  <a:srgbClr val="1E293B"/>
-                </a:solidFill>
-                <a:latin typeface="Calibri"/>
-              </a:rPr>
-              <a:t>· date_validation.py — проверка дат</a:t>
-            </a:r>
-          </a:p>
-          <a:p>
-            <a:pPr spcAft="200"/>
-          </a:p>
-          <a:p>
-            <a:pPr algn="l" spcAft="400"/>
-            <a:r>
-              <a:rPr sz="1500" b="1">
-                <a:solidFill>
-                  <a:srgbClr val="01773A"/>
-                </a:solidFill>
-                <a:latin typeface="Calibri"/>
-              </a:rPr>
-              <a:t>ДАННЫЕ</a:t>
-            </a:r>
-          </a:p>
-          <a:p>
-            <a:pPr algn="l" spcAft="100"/>
-            <a:r>
-              <a:rPr sz="1450">
-                <a:solidFill>
-                  <a:srgbClr val="1E293B"/>
-                </a:solidFill>
-                <a:latin typeface="Calibri"/>
-              </a:rPr>
-              <a:t>· MySQL — каталог, сессии, заявки</a:t>
-            </a:r>
-          </a:p>
-          <a:p>
-            <a:pPr algn="l" spcAft="100"/>
-            <a:r>
-              <a:rPr sz="1450">
-                <a:solidFill>
-                  <a:srgbClr val="1E293B"/>
-                </a:solidFill>
-                <a:latin typeface="Calibri"/>
-              </a:rPr>
-              <a:t>· GigaChat / DeepSeek — нейросети</a:t>
-            </a:r>
-          </a:p>
-          <a:p>
-            <a:pPr spcAft="200"/>
-          </a:p>
-          <a:p>
-            <a:pPr algn="l" spcAft="400"/>
-            <a:r>
-              <a:rPr sz="1500" b="1">
-                <a:solidFill>
-                  <a:srgbClr val="01773A"/>
-                </a:solidFill>
-                <a:latin typeface="Calibri"/>
-              </a:rPr>
-              <a:t>ПОТОК</a:t>
-            </a:r>
-          </a:p>
-          <a:p>
-            <a:pPr algn="l" spcAft="120"/>
-            <a:r>
-              <a:rPr sz="1450">
-                <a:solidFill>
-                  <a:srgbClr val="1E293B"/>
-                </a:solidFill>
-                <a:latin typeface="Calibri"/>
-              </a:rPr>
-              <a:t>Запрос → LLM → параметры → БД → турпакет → ответ</a:t>
+              <a:t>MySQL 8.0 — хранение каталога и сессий</a:t>
+            </a:r>
+          </a:p>
+          <a:p>
+            <a:pPr marL="280000" indent="-140000" spcAft="700">
+              <a:buChar char="●"/>
+            </a:pPr>
+            <a:r>
+              <a:rPr sz="1620">
+                <a:solidFill>
+                  <a:srgbClr val="1E293B"/>
+                </a:solidFill>
+                <a:latin typeface="Calibri"/>
+              </a:rPr>
+              <a:t>DeepSeek API + GigaChat — языковые модели</a:t>
+            </a:r>
+          </a:p>
+          <a:p>
+            <a:pPr marL="280000" indent="-140000" spcAft="700">
+              <a:buChar char="●"/>
+            </a:pPr>
+            <a:r>
+              <a:rPr sz="1620">
+                <a:solidFill>
+                  <a:srgbClr val="1E293B"/>
+                </a:solidFill>
+                <a:latin typeface="Calibri"/>
+              </a:rPr>
+              <a:t>BeautifulSoup + requests — парсинг bon-voyage28.ru</a:t>
+            </a:r>
+          </a:p>
+          <a:p>
+            <a:pPr marL="280000" indent="-140000" spcAft="700">
+              <a:buChar char="●"/>
+            </a:pPr>
+            <a:r>
+              <a:rPr sz="1620">
+                <a:solidFill>
+                  <a:srgbClr val="1E293B"/>
+                </a:solidFill>
+                <a:latin typeface="Calibri"/>
+              </a:rPr>
+              <a:t>Travelpayouts / Amadeus — данные о перелётах</a:t>
             </a:r>
           </a:p>
         </p:txBody>
@@ -7285,21 +5192,21 @@
                 </a:solidFill>
                 <a:latin typeface="Calibri"/>
               </a:rPr>
-              <a:t>7 / 15</a:t>
-            </a:r>
-          </a:p>
-        </p:txBody>
-      </p:sp>
-      <p:sp>
-        <p:nvSpPr>
-          <p:cNvPr id="15" name="leftC"/>
-          <p:cNvSpPr/>
-          <p:nvPr/>
-        </p:nvSpPr>
-        <p:spPr>
-          <a:xfrm>
-            <a:off x="480000" y="1120000"/>
-            <a:ext cx="4800000" cy="5000000"/>
+              <a:t>7 / 12</a:t>
+            </a:r>
+          </a:p>
+        </p:txBody>
+      </p:sp>
+      <p:sp>
+        <p:nvSpPr>
+          <p:cNvPr id="15" name="imgBg"/>
+          <p:cNvSpPr/>
+          <p:nvPr/>
+        </p:nvSpPr>
+        <p:spPr>
+          <a:xfrm>
+            <a:off x="360000" y="1080000"/>
+            <a:ext cx="11400000" cy="5150000"/>
           </a:xfrm>
           <a:prstGeom prst="roundRect">
             <a:avLst>
@@ -7307,7 +5214,7 @@
             </a:avLst>
           </a:prstGeom>
           <a:solidFill>
-            <a:srgbClr val="F0FDF4"/>
+            <a:srgbClr val="FFFFFF"/>
           </a:solidFill>
           <a:ln>
             <a:noFill/>
@@ -7320,48 +5227,20 @@
       </p:sp>
       <p:sp>
         <p:nvSpPr>
-          <p:cNvPr id="16" name="rightC"/>
-          <p:cNvSpPr/>
-          <p:nvPr/>
-        </p:nvSpPr>
-        <p:spPr>
-          <a:xfrm>
-            <a:off x="5400000" y="1120000"/>
-            <a:ext cx="6200000" cy="5000000"/>
+          <p:cNvPr id="16" name="imgBd"/>
+          <p:cNvSpPr/>
+          <p:nvPr/>
+        </p:nvSpPr>
+        <p:spPr>
+          <a:xfrm>
+            <a:off x="360000" y="1080000"/>
+            <a:ext cx="11400000" cy="5150000"/>
           </a:xfrm>
           <a:prstGeom prst="roundRect">
             <a:avLst>
               <a:gd name="adj" fmla="val 8000"/>
             </a:avLst>
           </a:prstGeom>
-          <a:solidFill>
-            <a:srgbClr val="FFFFFF"/>
-          </a:solidFill>
-          <a:ln>
-            <a:noFill/>
-          </a:ln>
-        </p:spPr>
-        <p:txBody>
-          <a:bodyPr/>
-          <a:lstStyle/>
-        </p:txBody>
-      </p:sp>
-      <p:sp>
-        <p:nvSpPr>
-          <p:cNvPr id="21" name="rightB"/>
-          <p:cNvSpPr/>
-          <p:nvPr/>
-        </p:nvSpPr>
-        <p:spPr>
-          <a:xfrm>
-            <a:off x="5400000" y="1120000"/>
-            <a:ext cx="6200000" cy="5000000"/>
-          </a:xfrm>
-          <a:prstGeom prst="roundRect">
-            <a:avLst>
-              <a:gd name="adj" fmla="val 8000"/>
-            </a:avLst>
-          </a:prstGeom>
           <a:noFill/>
           <a:ln w="12700">
             <a:solidFill>
@@ -7405,211 +5284,67 @@
                 </a:solidFill>
                 <a:latin typeface="Calibri Light"/>
               </a:rPr>
-              <a:t>Бизнес-процесс (IDEF0)</a:t>
-            </a:r>
-          </a:p>
-        </p:txBody>
-      </p:sp>
-      <p:sp>
-        <p:nvSpPr>
-          <p:cNvPr id="3" name="Body"/>
-          <p:cNvSpPr/>
-          <p:nvPr/>
-        </p:nvSpPr>
-        <p:spPr>
-          <a:xfrm>
-            <a:off x="600000" y="1200000"/>
-            <a:ext cx="4600000" cy="4800000"/>
-          </a:xfrm>
-          <a:prstGeom prst="rect">
-            <a:avLst/>
-          </a:prstGeom>
-          <a:noFill/>
-          <a:ln>
-            <a:noFill/>
-          </a:ln>
-        </p:spPr>
-        <p:txBody>
-          <a:bodyPr anchor="t" wrap="square" lIns="91440" tIns="45720" rIns="91440" bIns="45720"/>
-          <a:lstStyle/>
-          <a:p>
-            <a:pPr marL="280000" indent="-140000" spcAft="700">
-              <a:buChar char="●"/>
-            </a:pPr>
-            <a:r>
-              <a:rPr sz="1620">
-                <a:solidFill>
-                  <a:srgbClr val="1E293B"/>
-                </a:solidFill>
-                <a:latin typeface="Calibri"/>
-              </a:rPr>
-              <a:t>Деятельность турфирмы «Бон Вояж»</a:t>
-            </a:r>
-          </a:p>
-          <a:p>
-            <a:pPr marL="280000" indent="-140000" spcAft="700">
-              <a:buChar char="●"/>
-            </a:pPr>
-            <a:r>
-              <a:rPr sz="1620">
-                <a:solidFill>
-                  <a:srgbClr val="1E293B"/>
-                </a:solidFill>
-                <a:latin typeface="Calibri"/>
-              </a:rPr>
-              <a:t>5 этапов: A1 → A2 → A3 → A4 → A5</a:t>
-            </a:r>
-          </a:p>
-          <a:p>
-            <a:pPr marL="280000" indent="-140000" spcAft="700">
-              <a:buChar char="●"/>
-            </a:pPr>
-            <a:r>
-              <a:rPr sz="1620">
-                <a:solidFill>
-                  <a:srgbClr val="1E293B"/>
-                </a:solidFill>
-                <a:latin typeface="Calibri"/>
-              </a:rPr>
-              <a:t>Модуль автоматизирует этап A1</a:t>
-            </a:r>
-          </a:p>
-        </p:txBody>
-      </p:sp>
-      <p:sp>
-        <p:nvSpPr>
-          <p:cNvPr id="4" name="Detail"/>
-          <p:cNvSpPr/>
-          <p:nvPr/>
-        </p:nvSpPr>
-        <p:spPr>
-          <a:xfrm>
-            <a:off x="5520000" y="1180000"/>
-            <a:ext cx="6000000" cy="4900000"/>
-          </a:xfrm>
-          <a:prstGeom prst="rect">
-            <a:avLst/>
-          </a:prstGeom>
-          <a:noFill/>
-          <a:ln>
-            <a:noFill/>
-          </a:ln>
-        </p:spPr>
-        <p:txBody>
-          <a:bodyPr anchor="t" wrap="square" lIns="91440" tIns="45720" rIns="91440" bIns="45720"/>
-          <a:lstStyle/>
-          <a:p>
-            <a:pPr algn="l" spcAft="120"/>
-            <a:r>
-              <a:rPr sz="1450">
-                <a:solidFill>
-                  <a:srgbClr val="1E293B"/>
-                </a:solidFill>
-                <a:latin typeface="Calibri"/>
-              </a:rPr>
-              <a:t>A1 — Планирование поездки</a:t>
-            </a:r>
-          </a:p>
-          <a:p>
-            <a:pPr algn="l" spcAft="80"/>
-            <a:r>
-              <a:rPr sz="1400">
+              <a:t>База данных MySQL</a:t>
+            </a:r>
+          </a:p>
+        </p:txBody>
+      </p:sp>
+      <p:pic>
+        <p:nvPicPr>
+          <p:cNvPr id="22" name="ER Diagram"/>
+          <p:cNvPicPr>
+            <a:picLocks noChangeAspect="1"/>
+          </p:cNvPicPr>
+          <p:nvPr/>
+        </p:nvPicPr>
+        <p:blipFill>
+          <a:blip r:embed="rId3"/>
+          <a:stretch>
+            <a:fillRect/>
+          </a:stretch>
+        </p:blipFill>
+        <p:spPr>
+          <a:xfrm>
+            <a:off x="420000" y="1180000"/>
+            <a:ext cx="11300000" cy="4900000"/>
+          </a:xfrm>
+          <a:prstGeom prst="rect">
+            <a:avLst/>
+          </a:prstGeom>
+        </p:spPr>
+      </p:pic>
+      <p:sp>
+        <p:nvSpPr>
+          <p:cNvPr id="3" name="Caption"/>
+          <p:cNvSpPr/>
+          <p:nvPr/>
+        </p:nvSpPr>
+        <p:spPr>
+          <a:xfrm>
+            <a:off x="560000" y="6100000"/>
+            <a:ext cx="11000000" cy="200000"/>
+          </a:xfrm>
+          <a:prstGeom prst="rect">
+            <a:avLst/>
+          </a:prstGeom>
+          <a:noFill/>
+          <a:ln>
+            <a:noFill/>
+          </a:ln>
+        </p:spPr>
+        <p:txBody>
+          <a:bodyPr anchor="ctr" wrap="square" lIns="91440" tIns="45720" rIns="91440" bIns="45720"/>
+          <a:lstStyle/>
+          <a:p>
+            <a:pPr algn="ctr"/>
+            <a:r>
+              <a:rPr sz="1300">
                 <a:solidFill>
                   <a:srgbClr val="64748B"/>
                 </a:solidFill>
                 <a:latin typeface="Calibri"/>
               </a:rPr>
-              <a:t>Первичный подбор направления и тура</a:t>
-            </a:r>
-          </a:p>
-          <a:p>
-            <a:pPr algn="l" spcAft="400"/>
-            <a:r>
-              <a:rPr sz="1500" b="1">
-                <a:solidFill>
-                  <a:srgbClr val="01773A"/>
-                </a:solidFill>
-                <a:latin typeface="Calibri"/>
-              </a:rPr>
-              <a:t>   ← МОДУЛЬ АВТОМАТИЗИРУЕТ ЭТОТ ЭТАП</a:t>
-            </a:r>
-          </a:p>
-          <a:p>
-            <a:pPr spcAft="200"/>
-          </a:p>
-          <a:p>
-            <a:pPr algn="l" spcAft="120"/>
-            <a:r>
-              <a:rPr sz="1450">
-                <a:solidFill>
-                  <a:srgbClr val="1E293B"/>
-                </a:solidFill>
-                <a:latin typeface="Calibri"/>
-              </a:rPr>
-              <a:t>A2 — Формирование группы</a:t>
-            </a:r>
-          </a:p>
-          <a:p>
-            <a:pPr algn="l" spcAft="120"/>
-            <a:r>
-              <a:rPr sz="1450">
-                <a:solidFill>
-                  <a:srgbClr val="1E293B"/>
-                </a:solidFill>
-                <a:latin typeface="Calibri"/>
-              </a:rPr>
-              <a:t>A3 — Организация логистики</a:t>
-            </a:r>
-          </a:p>
-          <a:p>
-            <a:pPr algn="l" spcAft="120"/>
-            <a:r>
-              <a:rPr sz="1450">
-                <a:solidFill>
-                  <a:srgbClr val="1E293B"/>
-                </a:solidFill>
-                <a:latin typeface="Calibri"/>
-              </a:rPr>
-              <a:t>A4 — Сопровождение туристов</a:t>
-            </a:r>
-          </a:p>
-          <a:p>
-            <a:pPr algn="l" spcAft="120"/>
-            <a:r>
-              <a:rPr sz="1450">
-                <a:solidFill>
-                  <a:srgbClr val="1E293B"/>
-                </a:solidFill>
-                <a:latin typeface="Calibri"/>
-              </a:rPr>
-              <a:t>A5 — Отчётность и анализ</a:t>
-            </a:r>
-          </a:p>
-          <a:p>
-            <a:pPr spcAft="200"/>
-          </a:p>
-          <a:p>
-            <a:pPr algn="l" spcAft="120"/>
-            <a:r>
-              <a:rPr sz="1450">
-                <a:solidFill>
-                  <a:srgbClr val="1E293B"/>
-                </a:solidFill>
-                <a:latin typeface="Calibri"/>
-              </a:rPr>
-              <a:t>Вход: запрос клиента на сайте</a:t>
-            </a:r>
-          </a:p>
-          <a:p>
-            <a:pPr algn="l" spcAft="120"/>
-            <a:r>
-              <a:rPr sz="1450">
-                <a:solidFill>
-                  <a:srgbClr val="1E293B"/>
-                </a:solidFill>
-                <a:latin typeface="Calibri"/>
-              </a:rPr>
-              <a:t>Выход: готовый турпакет + заявка</a:t>
+              <a:t>7 таблиц: hotels, flights, user_sessions, user_queries, generated_tours, agency_leads, daily_stats</a:t>
             </a:r>
           </a:p>
         </p:txBody>
@@ -7888,21 +5623,21 @@
                 </a:solidFill>
                 <a:latin typeface="Calibri"/>
               </a:rPr>
-              <a:t>8 / 15</a:t>
-            </a:r>
-          </a:p>
-        </p:txBody>
-      </p:sp>
-      <p:sp>
-        <p:nvSpPr>
-          <p:cNvPr id="15" name="leftC"/>
+              <a:t>8 / 12</a:t>
+            </a:r>
+          </a:p>
+        </p:txBody>
+      </p:sp>
+      <p:sp>
+        <p:nvSpPr>
+          <p:cNvPr id="15" name="card"/>
           <p:cNvSpPr/>
           <p:nvPr/>
         </p:nvSpPr>
         <p:spPr>
           <a:xfrm>
             <a:off x="480000" y="1120000"/>
-            <a:ext cx="4800000" cy="5000000"/>
+            <a:ext cx="11000000" cy="5000000"/>
           </a:xfrm>
           <a:prstGeom prst="roundRect">
             <a:avLst>
@@ -7923,48 +5658,20 @@
       </p:sp>
       <p:sp>
         <p:nvSpPr>
-          <p:cNvPr id="16" name="rightC"/>
-          <p:cNvSpPr/>
-          <p:nvPr/>
-        </p:nvSpPr>
-        <p:spPr>
-          <a:xfrm>
-            <a:off x="5400000" y="1120000"/>
-            <a:ext cx="6200000" cy="5000000"/>
+          <p:cNvPr id="16" name="cardB"/>
+          <p:cNvSpPr/>
+          <p:nvPr/>
+        </p:nvSpPr>
+        <p:spPr>
+          <a:xfrm>
+            <a:off x="480000" y="1120000"/>
+            <a:ext cx="11000000" cy="5000000"/>
           </a:xfrm>
           <a:prstGeom prst="roundRect">
             <a:avLst>
               <a:gd name="adj" fmla="val 8000"/>
             </a:avLst>
           </a:prstGeom>
-          <a:solidFill>
-            <a:srgbClr val="FFFFFF"/>
-          </a:solidFill>
-          <a:ln>
-            <a:noFill/>
-          </a:ln>
-        </p:spPr>
-        <p:txBody>
-          <a:bodyPr/>
-          <a:lstStyle/>
-        </p:txBody>
-      </p:sp>
-      <p:sp>
-        <p:nvSpPr>
-          <p:cNvPr id="21" name="rightB"/>
-          <p:cNvSpPr/>
-          <p:nvPr/>
-        </p:nvSpPr>
-        <p:spPr>
-          <a:xfrm>
-            <a:off x="5400000" y="1120000"/>
-            <a:ext cx="6200000" cy="5000000"/>
-          </a:xfrm>
-          <a:prstGeom prst="roundRect">
-            <a:avLst>
-              <a:gd name="adj" fmla="val 8000"/>
-            </a:avLst>
-          </a:prstGeom>
           <a:noFill/>
           <a:ln w="12700">
             <a:solidFill>
@@ -7985,7 +5692,7 @@
         </p:nvSpPr>
         <p:spPr>
           <a:xfrm>
-            <a:off x="560000" y="1040000"/>
+            <a:off x="600000" y="1040000"/>
             <a:ext cx="10500000" cy="380000"/>
           </a:xfrm>
           <a:prstGeom prst="rect">
@@ -8008,7 +5715,7 @@
                 </a:solidFill>
                 <a:latin typeface="Calibri Light"/>
               </a:rPr>
-              <a:t>База данных MySQL</a:t>
+              <a:t>Интерфейс (фронтенд)</a:t>
             </a:r>
           </a:p>
         </p:txBody>
@@ -8021,8 +5728,8 @@
         </p:nvSpPr>
         <p:spPr>
           <a:xfrm>
-            <a:off x="600000" y="1200000"/>
-            <a:ext cx="4600000" cy="4800000"/>
+            <a:off x="680000" y="1200000"/>
+            <a:ext cx="10400000" cy="4900000"/>
           </a:xfrm>
           <a:prstGeom prst="rect">
             <a:avLst/>
@@ -8046,7 +5753,7 @@
                 </a:solidFill>
                 <a:latin typeface="Calibri"/>
               </a:rPr>
-              <a:t>6 таблиц в единой схеме</a:t>
+              <a:t>Одностраничное приложение на Vue.js (frontend/index.html)</a:t>
             </a:r>
           </a:p>
           <a:p>
@@ -8060,7 +5767,7 @@
                 </a:solidFill>
                 <a:latin typeface="Calibri"/>
               </a:rPr>
-              <a:t>Каталог, сессии, история, заявки</a:t>
+              <a:t>Чат: свободный ввод запроса на русском языке</a:t>
             </a:r>
           </a:p>
           <a:p>
@@ -8074,148 +5781,49 @@
                 </a:solidFill>
                 <a:latin typeface="Calibri"/>
               </a:rPr>
-              <a:t>Состояние диалога хранится в JSON</a:t>
-            </a:r>
-          </a:p>
-        </p:txBody>
-      </p:sp>
-      <p:sp>
-        <p:nvSpPr>
-          <p:cNvPr id="4" name="Detail"/>
-          <p:cNvSpPr/>
-          <p:nvPr/>
-        </p:nvSpPr>
-        <p:spPr>
-          <a:xfrm>
-            <a:off x="5520000" y="1180000"/>
-            <a:ext cx="6000000" cy="4900000"/>
-          </a:xfrm>
-          <a:prstGeom prst="rect">
-            <a:avLst/>
-          </a:prstGeom>
-          <a:noFill/>
-          <a:ln>
-            <a:noFill/>
-          </a:ln>
-        </p:spPr>
-        <p:txBody>
-          <a:bodyPr anchor="t" wrap="square" lIns="91440" tIns="45720" rIns="91440" bIns="45720"/>
-          <a:lstStyle/>
-          <a:p>
-            <a:pPr algn="l" spcAft="120"/>
-            <a:r>
-              <a:rPr sz="1450">
-                <a:solidFill>
-                  <a:srgbClr val="1E293B"/>
-                </a:solidFill>
-                <a:latin typeface="Calibri"/>
-              </a:rPr>
-              <a:t>hotels</a:t>
-            </a:r>
-          </a:p>
-          <a:p>
-            <a:pPr algn="l" spcAft="80"/>
-            <a:r>
-              <a:rPr sz="1400">
-                <a:solidFill>
-                  <a:srgbClr val="64748B"/>
-                </a:solidFill>
-                <a:latin typeface="Calibri"/>
-              </a:rPr>
-              <a:t>Каталог туров (парсер bon-voyage28.ru)</a:t>
-            </a:r>
-          </a:p>
-          <a:p>
-            <a:pPr algn="l" spcAft="80"/>
-            <a:r>
-              <a:rPr sz="1400">
-                <a:solidFill>
-                  <a:srgbClr val="64748B"/>
-                </a:solidFill>
-                <a:latin typeface="Calibri"/>
-              </a:rPr>
-              <a:t>name, country, price, dates</a:t>
-            </a:r>
-          </a:p>
-          <a:p>
-            <a:pPr spcAft="200"/>
-          </a:p>
-          <a:p>
-            <a:pPr algn="l" spcAft="120"/>
-            <a:r>
-              <a:rPr sz="1450">
-                <a:solidFill>
-                  <a:srgbClr val="1E293B"/>
-                </a:solidFill>
-                <a:latin typeface="Calibri"/>
-              </a:rPr>
-              <a:t>user_sessions</a:t>
-            </a:r>
-          </a:p>
-          <a:p>
-            <a:pPr algn="l" spcAft="80"/>
-            <a:r>
-              <a:rPr sz="1400">
-                <a:solidFill>
-                  <a:srgbClr val="64748B"/>
-                </a:solidFill>
-                <a:latin typeface="Calibri"/>
-              </a:rPr>
-              <a:t>session_id, state (JSON), updated_at</a:t>
-            </a:r>
-          </a:p>
-          <a:p>
-            <a:pPr spcAft="200"/>
-          </a:p>
-          <a:p>
-            <a:pPr algn="l" spcAft="120"/>
-            <a:r>
-              <a:rPr sz="1450">
-                <a:solidFill>
-                  <a:srgbClr val="1E293B"/>
-                </a:solidFill>
-                <a:latin typeface="Calibri"/>
-              </a:rPr>
-              <a:t>user_queries / generated_tours</a:t>
-            </a:r>
-          </a:p>
-          <a:p>
-            <a:pPr algn="l" spcAft="80"/>
-            <a:r>
-              <a:rPr sz="1400">
-                <a:solidFill>
-                  <a:srgbClr val="64748B"/>
-                </a:solidFill>
-                <a:latin typeface="Calibri"/>
-              </a:rPr>
-              <a:t>История сообщений и турпакетов</a:t>
-            </a:r>
-          </a:p>
-          <a:p>
-            <a:pPr spcAft="200"/>
-          </a:p>
-          <a:p>
-            <a:pPr algn="l" spcAft="120"/>
-            <a:r>
-              <a:rPr sz="1450">
-                <a:solidFill>
-                  <a:srgbClr val="1E293B"/>
-                </a:solidFill>
-                <a:latin typeface="Calibri"/>
-              </a:rPr>
-              <a:t>agency_leads / daily_stats</a:t>
-            </a:r>
-          </a:p>
-          <a:p>
-            <a:pPr algn="l" spcAft="80"/>
-            <a:r>
-              <a:rPr sz="1400">
-                <a:solidFill>
-                  <a:srgbClr val="64748B"/>
-                </a:solidFill>
-                <a:latin typeface="Calibri"/>
-              </a:rPr>
-              <a:t>Заявки клиентов и статистика</a:t>
+              <a:t>Выбор нейросети: Auto / GigaChat / DeepSeek</a:t>
+            </a:r>
+          </a:p>
+          <a:p>
+            <a:pPr marL="280000" indent="-140000" spcAft="700">
+              <a:buChar char="●"/>
+            </a:pPr>
+            <a:r>
+              <a:rPr sz="1620">
+                <a:solidFill>
+                  <a:srgbClr val="1E293B"/>
+                </a:solidFill>
+                <a:latin typeface="Calibri"/>
+              </a:rPr>
+              <a:t>Карточка тура: отель, перелёт, цена, рекомендация</a:t>
+            </a:r>
+          </a:p>
+          <a:p>
+            <a:pPr marL="280000" indent="-140000" spcAft="700">
+              <a:buChar char="●"/>
+            </a:pPr>
+            <a:r>
+              <a:rPr sz="1620">
+                <a:solidFill>
+                  <a:srgbClr val="1E293B"/>
+                </a:solidFill>
+                <a:latin typeface="Calibri"/>
+              </a:rPr>
+              <a:t>Кнопки «Купить самостоятельно» и «Обратиться в турфирму»</a:t>
+            </a:r>
+          </a:p>
+          <a:p>
+            <a:pPr marL="280000" indent="-140000" spcAft="700">
+              <a:buChar char="●"/>
+            </a:pPr>
+            <a:r>
+              <a:rPr sz="1620">
+                <a:solidFill>
+                  <a:srgbClr val="1E293B"/>
+                </a:solidFill>
+                <a:latin typeface="Calibri"/>
+              </a:rPr>
+              <a:t>Форма заявки: имя, телефон, email → менеджеру</a:t>
             </a:r>
           </a:p>
         </p:txBody>
@@ -8494,7 +6102,7 @@
                 </a:solidFill>
                 <a:latin typeface="Calibri"/>
               </a:rPr>
-              <a:t>9 / 15</a:t>
+              <a:t>9 / 12</a:t>
             </a:r>
           </a:p>
         </p:txBody>
@@ -8614,7 +6222,7 @@
                 </a:solidFill>
                 <a:latin typeface="Calibri Light"/>
               </a:rPr>
-              <a:t>Алгоритм AI-агента</a:t>
+              <a:t>Серверная часть (бэкенд)</a:t>
             </a:r>
           </a:p>
         </p:txBody>
@@ -8652,7 +6260,7 @@
                 </a:solidFill>
                 <a:latin typeface="Calibri"/>
               </a:rPr>
-              <a:t>Двухфазный алгоритм</a:t>
+              <a:t>FastAPI — центральный компонент (backend/app.py)</a:t>
             </a:r>
           </a:p>
           <a:p>
@@ -8666,7 +6274,7 @@
                 </a:solidFill>
                 <a:latin typeface="Calibri"/>
               </a:rPr>
-              <a:t>Серверная валидация параметров</a:t>
+              <a:t>POST /api/chat — приём сообщений и генерация тура</a:t>
             </a:r>
           </a:p>
           <a:p>
@@ -8680,7 +6288,49 @@
                 </a:solidFill>
                 <a:latin typeface="Calibri"/>
               </a:rPr>
-              <a:t>Отказоустойчивость при сбое LLM</a:t>
+              <a:t>ai_service.py — диалог LLM и сбор параметров</a:t>
+            </a:r>
+          </a:p>
+          <a:p>
+            <a:pPr marL="280000" indent="-140000" spcAft="700">
+              <a:buChar char="●"/>
+            </a:pPr>
+            <a:r>
+              <a:rPr sz="1620">
+                <a:solidFill>
+                  <a:srgbClr val="1E293B"/>
+                </a:solidFill>
+                <a:latin typeface="Calibri"/>
+              </a:rPr>
+              <a:t>database.py — SQL-запросы к MySQL</a:t>
+            </a:r>
+          </a:p>
+          <a:p>
+            <a:pPr marL="280000" indent="-140000" spcAft="700">
+              <a:buChar char="●"/>
+            </a:pPr>
+            <a:r>
+              <a:rPr sz="1620">
+                <a:solidFill>
+                  <a:srgbClr val="1E293B"/>
+                </a:solidFill>
+                <a:latin typeface="Calibri"/>
+              </a:rPr>
+              <a:t>date_validation.py, dialog_hints.py — серверная валидация</a:t>
+            </a:r>
+          </a:p>
+          <a:p>
+            <a:pPr marL="280000" indent="-140000" spcAft="700">
+              <a:buChar char="●"/>
+            </a:pPr>
+            <a:r>
+              <a:rPr sz="1620">
+                <a:solidFill>
+                  <a:srgbClr val="1E293B"/>
+                </a:solidFill>
+                <a:latin typeface="Calibri"/>
+              </a:rPr>
+              <a:t>Fallback: GigaChat → DeepSeek при сбое провайдера</a:t>
             </a:r>
           </a:p>
         </p:txBody>
@@ -8716,7 +6366,7 @@
                 </a:solidFill>
                 <a:latin typeface="Calibri"/>
               </a:rPr>
-              <a:t>1. Старт — POST /api/chat</a:t>
+              <a:t>АЛГОРИТМ /api/chat</a:t>
             </a:r>
           </a:p>
           <a:p>
@@ -8728,19 +6378,7 @@
                 </a:solidFill>
                 <a:latin typeface="Calibri"/>
               </a:rPr>
-              <a:t>2. Фаза 1 — диалог LLM:</a:t>
-            </a:r>
-          </a:p>
-          <a:p>
-            <a:pPr algn="l" spcAft="80"/>
-            <a:r>
-              <a:rPr sz="1400">
-                <a:solidFill>
-                  <a:srgbClr val="64748B"/>
-                </a:solidFill>
-                <a:latin typeface="Calibri"/>
-              </a:rPr>
-              <a:t>сбор направления, дат, бюджета</a:t>
+              <a:t>1. Создание/загрузка сессии</a:t>
             </a:r>
           </a:p>
           <a:p>
@@ -8752,7 +6390,7 @@
                 </a:solidFill>
                 <a:latin typeface="Calibri"/>
               </a:rPr>
-              <a:t>3. Валидация — date_validation.py</a:t>
+              <a:t>2. LLM извлекает направление, даты, бюджет</a:t>
             </a:r>
           </a:p>
           <a:p>
@@ -8764,7 +6402,7 @@
                 </a:solidFill>
                 <a:latin typeface="Calibri"/>
               </a:rPr>
-              <a:t>4. Поиск — SELECT из таблицы hotels</a:t>
+              <a:t>3. Поиск тура в таблице hotels</a:t>
             </a:r>
           </a:p>
           <a:p>
@@ -8776,7 +6414,7 @@
                 </a:solidFill>
                 <a:latin typeface="Calibri"/>
               </a:rPr>
-              <a:t>5. Фаза 2 — LLM формирует турпакет</a:t>
+              <a:t>4. LLM формирует турпакет + перелёт</a:t>
             </a:r>
           </a:p>
           <a:p>
@@ -8788,8 +6426,11 @@
                 </a:solidFill>
                 <a:latin typeface="Calibri"/>
               </a:rPr>
-              <a:t>6. Fallback — GigaChat → DeepSeek</a:t>
-            </a:r>
+              <a:t>5. Ответ клиенту в JSON</a:t>
+            </a:r>
+          </a:p>
+          <a:p>
+            <a:pPr spcAft="200"/>
           </a:p>
           <a:p>
             <a:pPr algn="l" spcAft="120"/>
@@ -8800,14 +6441,11 @@
                 </a:solidFill>
                 <a:latin typeface="Calibri"/>
               </a:rPr>
-              <a:t>7. Ответ — карточка тура в чате</a:t>
-            </a:r>
-          </a:p>
-          <a:p>
-            <a:pPr spcAft="200"/>
-          </a:p>
-          <a:p>
-            <a:pPr algn="l" spcAft="120"/>
+              <a:t>Дополнительно:</a:t>
+            </a:r>
+          </a:p>
+          <a:p>
+            <a:pPr algn="l" spcAft="100"/>
             <a:r>
               <a:rPr sz="1450">
                 <a:solidFill>
@@ -8815,11 +6453,11 @@
                 </a:solidFill>
                 <a:latin typeface="Calibri"/>
               </a:rPr>
-              <a:t>Режим auto: сначала GigaChat,</a:t>
-            </a:r>
-          </a:p>
-          <a:p>
-            <a:pPr algn="l" spcAft="120"/>
+              <a:t>· POST /api/reset — сброс диалога</a:t>
+            </a:r>
+          </a:p>
+          <a:p>
+            <a:pPr algn="l" spcAft="100"/>
             <a:r>
               <a:rPr sz="1450">
                 <a:solidFill>
@@ -8827,7 +6465,19 @@
                 </a:solidFill>
                 <a:latin typeface="Calibri"/>
               </a:rPr>
-              <a:t>при ошибке — автоматически DeepSeek</a:t>
+              <a:t>· POST /api/lead — заявка менеджеру</a:t>
+            </a:r>
+          </a:p>
+          <a:p>
+            <a:pPr algn="l" spcAft="100"/>
+            <a:r>
+              <a:rPr sz="1450">
+                <a:solidFill>
+                  <a:srgbClr val="1E293B"/>
+                </a:solidFill>
+                <a:latin typeface="Calibri"/>
+              </a:rPr>
+              <a:t>· GET /admin/stats — статистика</a:t>
             </a:r>
           </a:p>
         </p:txBody>

</xml_diff>